<commit_message>
fix: enable temperature/top_p in LLM calls, add r3agentv3 agent and evaluation scripts
Co-Authored-By: Claude Sonnet 4.6 (1M context) <noreply@anthropic.com>
</commit_message>
<xml_diff>
--- a/assets/libreoffice_impr_njc/16008ca9-7091-48b2-a22a-7a1ca1509109/The Evolution of Rock Music.pptx
+++ b/assets/libreoffice_impr_njc/16008ca9-7091-48b2-a22a-7a1ca1509109/The Evolution of Rock Music.pptx
@@ -2948,6 +2948,10 @@
           </a:gradFill>
           <a:ln/>
         </p:spPr>
+        <p:txBody>
+          <a:bodyPr/>
+          <a:p/>
+        </p:txBody>
       </p:sp>
       <p:sp>
         <p:nvSpPr>
@@ -2992,6 +2996,10 @@
           </a:solidFill>
           <a:ln/>
         </p:spPr>
+        <p:txBody>
+          <a:bodyPr/>
+          <a:p/>
+        </p:txBody>
       </p:sp>
       <p:sp>
         <p:nvSpPr>
@@ -3061,7 +3069,7 @@
               </a:lnSpc>
             </a:pPr>
             <a:r>
-              <a:rPr lang="en-US" sz="9000" b="1" spc="-450" kern="0" dirty="0">
+              <a:rPr lang="en-US" sz="3600" b="1" spc="-450" kern="0" dirty="0">
                 <a:solidFill>
                   <a:srgbClr val="FFFFFF"/>
                 </a:solidFill>
@@ -3080,7 +3088,7 @@
               </a:lnSpc>
             </a:pPr>
             <a:r>
-              <a:rPr lang="en-US" sz="9000" b="1" spc="-450" kern="0" dirty="0">
+              <a:rPr lang="en-US" sz="3600" b="1" spc="-450" kern="0" dirty="0">
                 <a:solidFill>
                   <a:srgbClr val="DDFF00"/>
                 </a:solidFill>
@@ -3099,7 +3107,7 @@
               </a:lnSpc>
             </a:pPr>
             <a:r>
-              <a:rPr lang="en-US" sz="9000" b="1" spc="-450" kern="0" dirty="0">
+              <a:rPr lang="en-US" sz="3600" b="1" spc="-450" kern="0" dirty="0">
                 <a:solidFill>
                   <a:srgbClr val="FFFFFF"/>
                 </a:solidFill>
@@ -3156,6 +3164,10 @@
           </a:solidFill>
           <a:ln/>
         </p:spPr>
+        <p:txBody>
+          <a:bodyPr/>
+          <a:p/>
+        </p:txBody>
       </p:sp>
       <p:sp>
         <p:nvSpPr>
@@ -3200,6 +3212,10 @@
           </a:solidFill>
           <a:ln/>
         </p:spPr>
+        <p:txBody>
+          <a:bodyPr/>
+          <a:p/>
+        </p:txBody>
       </p:sp>
       <p:sp>
         <p:nvSpPr>
@@ -3244,6 +3260,10 @@
           </a:solidFill>
           <a:ln/>
         </p:spPr>
+        <p:txBody>
+          <a:bodyPr/>
+          <a:p/>
+        </p:txBody>
       </p:sp>
       <p:sp>
         <p:nvSpPr>
@@ -3343,6 +3363,10 @@
             </a:outerShdw>
           </a:effectLst>
         </p:spPr>
+        <p:txBody>
+          <a:bodyPr/>
+          <a:p/>
+        </p:txBody>
       </p:sp>
       <p:sp>
         <p:nvSpPr>
@@ -3448,6 +3472,10 @@
           </a:solidFill>
           <a:ln/>
         </p:spPr>
+        <p:txBody>
+          <a:bodyPr/>
+          <a:p/>
+        </p:txBody>
       </p:sp>
     </p:spTree>
   </p:cSld>
@@ -3524,6 +3552,10 @@
           </a:solidFill>
           <a:ln/>
         </p:spPr>
+        <p:txBody>
+          <a:bodyPr/>
+          <a:p/>
+        </p:txBody>
       </p:sp>
       <p:sp>
         <p:nvSpPr>
@@ -3593,7 +3625,7 @@
               </a:lnSpc>
             </a:pPr>
             <a:r>
-              <a:rPr lang="en-US" sz="2319" b="1" dirty="0">
+              <a:rPr lang="en-US" sz="3600" b="1" dirty="0">
                 <a:solidFill>
                   <a:srgbClr val="FFFFFF"/>
                 </a:solidFill>
@@ -3650,6 +3682,10 @@
           </a:solidFill>
           <a:ln/>
         </p:spPr>
+        <p:txBody>
+          <a:bodyPr/>
+          <a:p/>
+        </p:txBody>
       </p:sp>
       <p:sp>
         <p:nvSpPr>
@@ -3842,6 +3878,10 @@
             <a:prstDash val="solid"/>
           </a:ln>
         </p:spPr>
+        <p:txBody>
+          <a:bodyPr/>
+          <a:p/>
+        </p:txBody>
       </p:sp>
       <p:sp>
         <p:nvSpPr>
@@ -3934,6 +3974,10 @@
             <a:prstDash val="solid"/>
           </a:ln>
         </p:spPr>
+        <p:txBody>
+          <a:bodyPr/>
+          <a:p/>
+        </p:txBody>
       </p:sp>
       <p:sp>
         <p:nvSpPr>
@@ -4112,6 +4156,10 @@
             <a:prstDash val="solid"/>
           </a:ln>
         </p:spPr>
+        <p:txBody>
+          <a:bodyPr/>
+          <a:p/>
+        </p:txBody>
       </p:sp>
       <p:sp>
         <p:nvSpPr>
@@ -4290,6 +4338,10 @@
             <a:prstDash val="solid"/>
           </a:ln>
         </p:spPr>
+        <p:txBody>
+          <a:bodyPr/>
+          <a:p/>
+        </p:txBody>
       </p:sp>
       <p:sp>
         <p:nvSpPr>
@@ -4468,6 +4520,10 @@
             <a:prstDash val="solid"/>
           </a:ln>
         </p:spPr>
+        <p:txBody>
+          <a:bodyPr/>
+          <a:p/>
+        </p:txBody>
       </p:sp>
       <p:sp>
         <p:nvSpPr>
@@ -4639,6 +4695,10 @@
           </a:solidFill>
           <a:ln/>
         </p:spPr>
+        <p:txBody>
+          <a:bodyPr/>
+          <a:p/>
+        </p:txBody>
       </p:sp>
       <p:sp>
         <p:nvSpPr>
@@ -4772,6 +4832,10 @@
           </a:solidFill>
           <a:ln/>
         </p:spPr>
+        <p:txBody>
+          <a:bodyPr/>
+          <a:p/>
+        </p:txBody>
       </p:sp>
       <p:sp>
         <p:nvSpPr>
@@ -4857,6 +4921,10 @@
           </a:solidFill>
           <a:ln/>
         </p:spPr>
+        <p:txBody>
+          <a:bodyPr/>
+          <a:p/>
+        </p:txBody>
       </p:sp>
       <p:sp>
         <p:nvSpPr>
@@ -4974,6 +5042,10 @@
           </a:solidFill>
           <a:ln/>
         </p:spPr>
+        <p:txBody>
+          <a:bodyPr/>
+          <a:p/>
+        </p:txBody>
       </p:sp>
       <p:sp>
         <p:nvSpPr>
@@ -5059,6 +5131,10 @@
           </a:solidFill>
           <a:ln/>
         </p:spPr>
+        <p:txBody>
+          <a:bodyPr/>
+          <a:p/>
+        </p:txBody>
       </p:sp>
       <p:sp>
         <p:nvSpPr>
@@ -5209,6 +5285,10 @@
           </a:solidFill>
           <a:ln/>
         </p:spPr>
+        <p:txBody>
+          <a:bodyPr/>
+          <a:p/>
+        </p:txBody>
       </p:sp>
       <p:sp>
         <p:nvSpPr>
@@ -5294,6 +5374,10 @@
           </a:solidFill>
           <a:ln/>
         </p:spPr>
+        <p:txBody>
+          <a:bodyPr/>
+          <a:p/>
+        </p:txBody>
       </p:sp>
       <p:sp>
         <p:nvSpPr>
@@ -5384,6 +5468,10 @@
           </a:solidFill>
           <a:ln/>
         </p:spPr>
+        <p:txBody>
+          <a:bodyPr/>
+          <a:p/>
+        </p:txBody>
       </p:sp>
       <p:sp>
         <p:nvSpPr>
@@ -5509,6 +5597,10 @@
           </a:gradFill>
           <a:ln/>
         </p:spPr>
+        <p:txBody>
+          <a:bodyPr/>
+          <a:p/>
+        </p:txBody>
       </p:sp>
       <p:sp>
         <p:nvSpPr>
@@ -5642,6 +5734,10 @@
             <a:prstDash val="solid"/>
           </a:ln>
         </p:spPr>
+        <p:txBody>
+          <a:bodyPr/>
+          <a:p/>
+        </p:txBody>
       </p:sp>
       <p:sp>
         <p:nvSpPr>
@@ -5727,6 +5823,10 @@
           </a:solidFill>
           <a:ln/>
         </p:spPr>
+        <p:txBody>
+          <a:bodyPr/>
+          <a:p/>
+        </p:txBody>
       </p:sp>
       <p:sp>
         <p:nvSpPr>
@@ -5832,6 +5932,10 @@
           </a:solidFill>
           <a:ln/>
         </p:spPr>
+        <p:txBody>
+          <a:bodyPr/>
+          <a:p/>
+        </p:txBody>
       </p:sp>
       <p:sp>
         <p:nvSpPr>
@@ -5937,6 +6041,10 @@
           </a:solidFill>
           <a:ln/>
         </p:spPr>
+        <p:txBody>
+          <a:bodyPr/>
+          <a:p/>
+        </p:txBody>
       </p:sp>
       <p:sp>
         <p:nvSpPr>
@@ -6024,6 +6132,10 @@
           </a:solidFill>
           <a:ln/>
         </p:spPr>
+        <p:txBody>
+          <a:bodyPr/>
+          <a:p/>
+        </p:txBody>
       </p:sp>
       <p:sp>
         <p:nvSpPr>
@@ -6129,6 +6241,10 @@
           </a:solidFill>
           <a:ln/>
         </p:spPr>
+        <p:txBody>
+          <a:bodyPr/>
+          <a:p/>
+        </p:txBody>
       </p:sp>
       <p:sp>
         <p:nvSpPr>
@@ -6248,6 +6364,10 @@
           </a:solidFill>
           <a:ln/>
         </p:spPr>
+        <p:txBody>
+          <a:bodyPr/>
+          <a:p/>
+        </p:txBody>
       </p:sp>
       <p:sp>
         <p:nvSpPr>
@@ -6317,7 +6437,7 @@
               </a:lnSpc>
             </a:pPr>
             <a:r>
-              <a:rPr lang="en-US" sz="2250" b="1" dirty="0">
+              <a:rPr lang="en-US" sz="3600" b="1" dirty="0">
                 <a:solidFill>
                   <a:srgbClr val="FFFFFF"/>
                 </a:solidFill>
@@ -6374,6 +6494,10 @@
           </a:solidFill>
           <a:ln/>
         </p:spPr>
+        <p:txBody>
+          <a:bodyPr/>
+          <a:p/>
+        </p:txBody>
       </p:sp>
       <p:sp>
         <p:nvSpPr>
@@ -6566,6 +6690,10 @@
             <a:prstDash val="solid"/>
           </a:ln>
         </p:spPr>
+        <p:txBody>
+          <a:bodyPr/>
+          <a:p/>
+        </p:txBody>
       </p:sp>
       <p:sp>
         <p:nvSpPr>
@@ -6651,6 +6779,10 @@
           </a:solidFill>
           <a:ln/>
         </p:spPr>
+        <p:txBody>
+          <a:bodyPr/>
+          <a:p/>
+        </p:txBody>
       </p:sp>
       <p:sp>
         <p:nvSpPr>
@@ -6695,6 +6827,10 @@
           </a:solidFill>
           <a:ln/>
         </p:spPr>
+        <p:txBody>
+          <a:bodyPr/>
+          <a:p/>
+        </p:txBody>
       </p:sp>
       <p:sp>
         <p:nvSpPr>
@@ -6849,6 +6985,10 @@
           </a:solidFill>
           <a:ln/>
         </p:spPr>
+        <p:txBody>
+          <a:bodyPr/>
+          <a:p/>
+        </p:txBody>
       </p:sp>
       <p:sp>
         <p:nvSpPr>
@@ -6977,6 +7117,10 @@
           </a:solidFill>
           <a:ln/>
         </p:spPr>
+        <p:txBody>
+          <a:bodyPr/>
+          <a:p/>
+        </p:txBody>
       </p:sp>
       <p:sp>
         <p:nvSpPr>
@@ -7021,6 +7165,10 @@
           </a:solidFill>
           <a:ln/>
         </p:spPr>
+        <p:txBody>
+          <a:bodyPr/>
+          <a:p/>
+        </p:txBody>
       </p:sp>
       <p:sp>
         <p:nvSpPr>
@@ -7111,6 +7259,10 @@
           </a:solidFill>
           <a:ln/>
         </p:spPr>
+        <p:txBody>
+          <a:bodyPr/>
+          <a:p/>
+        </p:txBody>
       </p:sp>
       <p:sp>
         <p:nvSpPr>
@@ -7239,6 +7391,10 @@
           </a:solidFill>
           <a:ln/>
         </p:spPr>
+        <p:txBody>
+          <a:bodyPr/>
+          <a:p/>
+        </p:txBody>
       </p:sp>
       <p:sp>
         <p:nvSpPr>
@@ -7283,6 +7439,10 @@
           </a:solidFill>
           <a:ln/>
         </p:spPr>
+        <p:txBody>
+          <a:bodyPr/>
+          <a:p/>
+        </p:txBody>
       </p:sp>
       <p:sp>
         <p:nvSpPr>
@@ -7440,6 +7600,10 @@
           </a:solidFill>
           <a:ln/>
         </p:spPr>
+        <p:txBody>
+          <a:bodyPr/>
+          <a:p/>
+        </p:txBody>
       </p:sp>
       <p:sp>
         <p:nvSpPr>
@@ -7568,6 +7732,10 @@
           </a:solidFill>
           <a:ln/>
         </p:spPr>
+        <p:txBody>
+          <a:bodyPr/>
+          <a:p/>
+        </p:txBody>
       </p:sp>
       <p:sp>
         <p:nvSpPr>
@@ -7612,6 +7780,10 @@
           </a:solidFill>
           <a:ln/>
         </p:spPr>
+        <p:txBody>
+          <a:bodyPr/>
+          <a:p/>
+        </p:txBody>
       </p:sp>
       <p:sp>
         <p:nvSpPr>
@@ -7702,6 +7874,10 @@
           </a:solidFill>
           <a:ln/>
         </p:spPr>
+        <p:txBody>
+          <a:bodyPr/>
+          <a:p/>
+        </p:txBody>
       </p:sp>
       <p:sp>
         <p:nvSpPr>
@@ -7837,6 +8013,10 @@
             <a:prstDash val="solid"/>
           </a:ln>
         </p:spPr>
+        <p:txBody>
+          <a:bodyPr/>
+          <a:p/>
+        </p:txBody>
       </p:sp>
       <p:sp>
         <p:nvSpPr>
@@ -7922,6 +8102,10 @@
           </a:solidFill>
           <a:ln/>
         </p:spPr>
+        <p:txBody>
+          <a:bodyPr/>
+          <a:p/>
+        </p:txBody>
       </p:sp>
       <p:sp>
         <p:nvSpPr>
@@ -8091,6 +8275,10 @@
           </a:solidFill>
           <a:ln/>
         </p:spPr>
+        <p:txBody>
+          <a:bodyPr/>
+          <a:p/>
+        </p:txBody>
       </p:sp>
       <p:sp>
         <p:nvSpPr>
@@ -8260,6 +8448,10 @@
           </a:solidFill>
           <a:ln/>
         </p:spPr>
+        <p:txBody>
+          <a:bodyPr/>
+          <a:p/>
+        </p:txBody>
       </p:sp>
       <p:sp>
         <p:nvSpPr>
@@ -8429,6 +8621,10 @@
           </a:solidFill>
           <a:ln/>
         </p:spPr>
+        <p:txBody>
+          <a:bodyPr/>
+          <a:p/>
+        </p:txBody>
       </p:sp>
       <p:sp>
         <p:nvSpPr>
@@ -8598,6 +8794,10 @@
           </a:solidFill>
           <a:ln/>
         </p:spPr>
+        <p:txBody>
+          <a:bodyPr/>
+          <a:p/>
+        </p:txBody>
       </p:sp>
       <p:sp>
         <p:nvSpPr>
@@ -8713,6 +8913,10 @@
           </a:solidFill>
           <a:ln/>
         </p:spPr>
+        <p:txBody>
+          <a:bodyPr/>
+          <a:p/>
+        </p:txBody>
       </p:sp>
       <p:sp>
         <p:nvSpPr>
@@ -8828,6 +9032,10 @@
           </a:solidFill>
           <a:ln/>
         </p:spPr>
+        <p:txBody>
+          <a:bodyPr/>
+          <a:p/>
+        </p:txBody>
       </p:sp>
       <p:sp>
         <p:nvSpPr>
@@ -8943,6 +9151,10 @@
           </a:solidFill>
           <a:ln/>
         </p:spPr>
+        <p:txBody>
+          <a:bodyPr/>
+          <a:p/>
+        </p:txBody>
       </p:sp>
       <p:sp>
         <p:nvSpPr>
@@ -9058,6 +9270,10 @@
           </a:solidFill>
           <a:ln/>
         </p:spPr>
+        <p:txBody>
+          <a:bodyPr/>
+          <a:p/>
+        </p:txBody>
       </p:sp>
       <p:sp>
         <p:nvSpPr>
@@ -9173,6 +9389,10 @@
           </a:solidFill>
           <a:ln/>
         </p:spPr>
+        <p:txBody>
+          <a:bodyPr/>
+          <a:p/>
+        </p:txBody>
       </p:sp>
       <p:sp>
         <p:nvSpPr>
@@ -9288,6 +9508,10 @@
           </a:solidFill>
           <a:ln/>
         </p:spPr>
+        <p:txBody>
+          <a:bodyPr/>
+          <a:p/>
+        </p:txBody>
       </p:sp>
       <p:sp>
         <p:nvSpPr>
@@ -9447,6 +9671,10 @@
           </a:gradFill>
           <a:ln/>
         </p:spPr>
+        <p:txBody>
+          <a:bodyPr/>
+          <a:p/>
+        </p:txBody>
       </p:sp>
       <p:sp>
         <p:nvSpPr>
@@ -9498,6 +9726,10 @@
             <a:prstDash val="solid"/>
           </a:ln>
         </p:spPr>
+        <p:txBody>
+          <a:bodyPr/>
+          <a:p/>
+        </p:txBody>
       </p:sp>
       <p:sp>
         <p:nvSpPr>
@@ -9542,6 +9774,10 @@
           </a:solidFill>
           <a:ln/>
         </p:spPr>
+        <p:txBody>
+          <a:bodyPr/>
+          <a:p/>
+        </p:txBody>
       </p:sp>
       <p:sp>
         <p:nvSpPr>
@@ -9627,6 +9863,10 @@
           </a:solidFill>
           <a:ln/>
         </p:spPr>
+        <p:txBody>
+          <a:bodyPr/>
+          <a:p/>
+        </p:txBody>
       </p:sp>
       <p:sp>
         <p:nvSpPr>
@@ -9696,7 +9936,7 @@
               </a:lnSpc>
             </a:pPr>
             <a:r>
-              <a:rPr lang="en-US" sz="5400" b="1" dirty="0">
+              <a:rPr lang="en-US" sz="3600" b="1" dirty="0">
                 <a:solidFill>
                   <a:srgbClr val="FFFFFF"/>
                 </a:solidFill>
@@ -9715,7 +9955,7 @@
               </a:lnSpc>
             </a:pPr>
             <a:r>
-              <a:rPr lang="en-US" sz="5400" b="1" dirty="0">
+              <a:rPr lang="en-US" sz="3600" b="1" dirty="0">
                 <a:solidFill>
                   <a:srgbClr val="DDFF00"/>
                 </a:solidFill>
@@ -9815,6 +10055,10 @@
           </a:solidFill>
           <a:ln/>
         </p:spPr>
+        <p:txBody>
+          <a:bodyPr/>
+          <a:p/>
+        </p:txBody>
       </p:sp>
       <p:sp>
         <p:nvSpPr>
@@ -9859,6 +10103,10 @@
           </a:solidFill>
           <a:ln/>
         </p:spPr>
+        <p:txBody>
+          <a:bodyPr/>
+          <a:p/>
+        </p:txBody>
       </p:sp>
       <p:sp>
         <p:nvSpPr>
@@ -9903,6 +10151,10 @@
           </a:solidFill>
           <a:ln/>
         </p:spPr>
+        <p:txBody>
+          <a:bodyPr/>
+          <a:p/>
+        </p:txBody>
       </p:sp>
     </p:spTree>
   </p:cSld>
@@ -9979,6 +10231,10 @@
           </a:solidFill>
           <a:ln/>
         </p:spPr>
+        <p:txBody>
+          <a:bodyPr/>
+          <a:p/>
+        </p:txBody>
       </p:sp>
       <p:sp>
         <p:nvSpPr>
@@ -10048,7 +10304,7 @@
               </a:lnSpc>
             </a:pPr>
             <a:r>
-              <a:rPr lang="en-US" sz="2250" b="1" dirty="0">
+              <a:rPr lang="en-US" sz="3600" b="1" dirty="0">
                 <a:solidFill>
                   <a:srgbClr val="FFFFFF"/>
                 </a:solidFill>
@@ -10105,6 +10361,10 @@
           </a:solidFill>
           <a:ln/>
         </p:spPr>
+        <p:txBody>
+          <a:bodyPr/>
+          <a:p/>
+        </p:txBody>
       </p:sp>
       <p:sp>
         <p:nvSpPr>
@@ -10297,6 +10557,10 @@
             <a:prstDash val="solid"/>
           </a:ln>
         </p:spPr>
+        <p:txBody>
+          <a:bodyPr/>
+          <a:p/>
+        </p:txBody>
       </p:sp>
       <p:sp>
         <p:nvSpPr>
@@ -10341,6 +10605,10 @@
           </a:solidFill>
           <a:ln/>
         </p:spPr>
+        <p:txBody>
+          <a:bodyPr/>
+          <a:p/>
+        </p:txBody>
       </p:sp>
       <p:sp>
         <p:nvSpPr>
@@ -10431,6 +10699,10 @@
           </a:solidFill>
           <a:ln/>
         </p:spPr>
+        <p:txBody>
+          <a:bodyPr/>
+          <a:p/>
+        </p:txBody>
       </p:sp>
       <p:sp>
         <p:nvSpPr>
@@ -10803,6 +11075,10 @@
           </a:solidFill>
           <a:ln/>
         </p:spPr>
+        <p:txBody>
+          <a:bodyPr/>
+          <a:p/>
+        </p:txBody>
       </p:sp>
       <p:sp>
         <p:nvSpPr>
@@ -10897,6 +11173,10 @@
             <a:prstDash val="solid"/>
           </a:ln>
         </p:spPr>
+        <p:txBody>
+          <a:bodyPr/>
+          <a:p/>
+        </p:txBody>
       </p:sp>
       <p:sp>
         <p:nvSpPr>
@@ -10941,6 +11221,10 @@
           </a:solidFill>
           <a:ln/>
         </p:spPr>
+        <p:txBody>
+          <a:bodyPr/>
+          <a:p/>
+        </p:txBody>
       </p:sp>
       <p:sp>
         <p:nvSpPr>
@@ -11098,6 +11382,10 @@
           </a:solidFill>
           <a:ln/>
         </p:spPr>
+        <p:txBody>
+          <a:bodyPr/>
+          <a:p/>
+        </p:txBody>
       </p:sp>
       <p:sp>
         <p:nvSpPr>
@@ -11470,6 +11758,10 @@
           </a:solidFill>
           <a:ln/>
         </p:spPr>
+        <p:txBody>
+          <a:bodyPr/>
+          <a:p/>
+        </p:txBody>
       </p:sp>
       <p:sp>
         <p:nvSpPr>
@@ -11564,6 +11856,10 @@
             <a:prstDash val="solid"/>
           </a:ln>
         </p:spPr>
+        <p:txBody>
+          <a:bodyPr/>
+          <a:p/>
+        </p:txBody>
       </p:sp>
       <p:sp>
         <p:nvSpPr>
@@ -11608,6 +11904,10 @@
           </a:solidFill>
           <a:ln/>
         </p:spPr>
+        <p:txBody>
+          <a:bodyPr/>
+          <a:p/>
+        </p:txBody>
       </p:sp>
       <p:sp>
         <p:nvSpPr>
@@ -11741,6 +12041,10 @@
           </a:solidFill>
           <a:ln/>
         </p:spPr>
+        <p:txBody>
+          <a:bodyPr/>
+          <a:p/>
+        </p:txBody>
       </p:sp>
       <p:sp>
         <p:nvSpPr>
@@ -12113,6 +12417,10 @@
           </a:solidFill>
           <a:ln/>
         </p:spPr>
+        <p:txBody>
+          <a:bodyPr/>
+          <a:p/>
+        </p:txBody>
       </p:sp>
       <p:sp>
         <p:nvSpPr>
@@ -12240,6 +12548,10 @@
           </a:gradFill>
           <a:ln/>
         </p:spPr>
+        <p:txBody>
+          <a:bodyPr/>
+          <a:p/>
+        </p:txBody>
       </p:sp>
       <p:sp>
         <p:nvSpPr>
@@ -12366,6 +12678,10 @@
           </a:solidFill>
           <a:ln/>
         </p:spPr>
+        <p:txBody>
+          <a:bodyPr/>
+          <a:p/>
+        </p:txBody>
       </p:sp>
       <p:sp>
         <p:nvSpPr>
@@ -12625,6 +12941,10 @@
           </a:gradFill>
           <a:ln/>
         </p:spPr>
+        <p:txBody>
+          <a:bodyPr/>
+          <a:p/>
+        </p:txBody>
       </p:sp>
       <p:sp>
         <p:nvSpPr>
@@ -12676,6 +12996,10 @@
             <a:prstDash val="solid"/>
           </a:ln>
         </p:spPr>
+        <p:txBody>
+          <a:bodyPr/>
+          <a:p/>
+        </p:txBody>
       </p:sp>
       <p:sp>
         <p:nvSpPr>
@@ -12720,6 +13044,10 @@
           </a:solidFill>
           <a:ln/>
         </p:spPr>
+        <p:txBody>
+          <a:bodyPr/>
+          <a:p/>
+        </p:txBody>
       </p:sp>
       <p:sp>
         <p:nvSpPr>
@@ -12805,6 +13133,10 @@
           </a:solidFill>
           <a:ln/>
         </p:spPr>
+        <p:txBody>
+          <a:bodyPr/>
+          <a:p/>
+        </p:txBody>
       </p:sp>
       <p:sp>
         <p:nvSpPr>
@@ -12874,7 +13206,7 @@
               </a:lnSpc>
             </a:pPr>
             <a:r>
-              <a:rPr lang="en-US" sz="5400" b="1" dirty="0">
+              <a:rPr lang="en-US" sz="3600" b="1" dirty="0">
                 <a:solidFill>
                   <a:srgbClr val="FFFFFF"/>
                 </a:solidFill>
@@ -12893,7 +13225,7 @@
               </a:lnSpc>
             </a:pPr>
             <a:r>
-              <a:rPr lang="en-US" sz="5400" b="1" dirty="0">
+              <a:rPr lang="en-US" sz="3600" b="1" dirty="0">
                 <a:solidFill>
                   <a:srgbClr val="DDFF00"/>
                 </a:solidFill>
@@ -12993,6 +13325,10 @@
           </a:solidFill>
           <a:ln/>
         </p:spPr>
+        <p:txBody>
+          <a:bodyPr/>
+          <a:p/>
+        </p:txBody>
       </p:sp>
       <p:sp>
         <p:nvSpPr>
@@ -13037,6 +13373,10 @@
           </a:solidFill>
           <a:ln/>
         </p:spPr>
+        <p:txBody>
+          <a:bodyPr/>
+          <a:p/>
+        </p:txBody>
       </p:sp>
       <p:sp>
         <p:nvSpPr>
@@ -13081,6 +13421,10 @@
           </a:solidFill>
           <a:ln/>
         </p:spPr>
+        <p:txBody>
+          <a:bodyPr/>
+          <a:p/>
+        </p:txBody>
       </p:sp>
     </p:spTree>
   </p:cSld>
@@ -13157,6 +13501,10 @@
           </a:solidFill>
           <a:ln/>
         </p:spPr>
+        <p:txBody>
+          <a:bodyPr/>
+          <a:p/>
+        </p:txBody>
       </p:sp>
       <p:sp>
         <p:nvSpPr>
@@ -13226,7 +13574,7 @@
               </a:lnSpc>
             </a:pPr>
             <a:r>
-              <a:rPr lang="en-US" sz="2366" b="1" dirty="0">
+              <a:rPr lang="en-US" sz="3600" b="1" dirty="0">
                 <a:solidFill>
                   <a:srgbClr val="FFFFFF"/>
                 </a:solidFill>
@@ -13283,6 +13631,10 @@
           </a:solidFill>
           <a:ln/>
         </p:spPr>
+        <p:txBody>
+          <a:bodyPr/>
+          <a:p/>
+        </p:txBody>
       </p:sp>
       <p:sp>
         <p:nvSpPr>
@@ -13475,6 +13827,10 @@
             <a:prstDash val="solid"/>
           </a:ln>
         </p:spPr>
+        <p:txBody>
+          <a:bodyPr/>
+          <a:p/>
+        </p:txBody>
       </p:sp>
       <p:sp>
         <p:nvSpPr>
@@ -13560,6 +13916,10 @@
           </a:solidFill>
           <a:ln/>
         </p:spPr>
+        <p:txBody>
+          <a:bodyPr/>
+          <a:p/>
+        </p:txBody>
       </p:sp>
       <p:sp>
         <p:nvSpPr>
@@ -13731,6 +14091,10 @@
           </a:solidFill>
           <a:ln/>
         </p:spPr>
+        <p:txBody>
+          <a:bodyPr/>
+          <a:p/>
+        </p:txBody>
       </p:sp>
       <p:sp>
         <p:nvSpPr>
@@ -13902,6 +14266,10 @@
           </a:solidFill>
           <a:ln/>
         </p:spPr>
+        <p:txBody>
+          <a:bodyPr/>
+          <a:p/>
+        </p:txBody>
       </p:sp>
       <p:sp>
         <p:nvSpPr>
@@ -14073,6 +14441,10 @@
           </a:solidFill>
           <a:ln/>
         </p:spPr>
+        <p:txBody>
+          <a:bodyPr/>
+          <a:p/>
+        </p:txBody>
       </p:sp>
       <p:sp>
         <p:nvSpPr>
@@ -14251,6 +14623,10 @@
             <a:prstDash val="solid"/>
           </a:ln>
         </p:spPr>
+        <p:txBody>
+          <a:bodyPr/>
+          <a:p/>
+        </p:txBody>
       </p:sp>
       <p:sp>
         <p:nvSpPr>
@@ -14341,6 +14717,10 @@
           </a:solidFill>
           <a:ln/>
         </p:spPr>
+        <p:txBody>
+          <a:bodyPr/>
+          <a:p/>
+        </p:txBody>
       </p:sp>
       <p:sp>
         <p:nvSpPr>
@@ -14433,6 +14813,10 @@
             <a:prstDash val="solid"/>
           </a:ln>
         </p:spPr>
+        <p:txBody>
+          <a:bodyPr/>
+          <a:p/>
+        </p:txBody>
       </p:sp>
       <p:sp>
         <p:nvSpPr>
@@ -14676,6 +15060,10 @@
           </a:solidFill>
           <a:ln/>
         </p:spPr>
+        <p:txBody>
+          <a:bodyPr/>
+          <a:p/>
+        </p:txBody>
       </p:sp>
       <p:sp>
         <p:nvSpPr>
@@ -14768,6 +15156,10 @@
             <a:prstDash val="solid"/>
           </a:ln>
         </p:spPr>
+        <p:txBody>
+          <a:bodyPr/>
+          <a:p/>
+        </p:txBody>
       </p:sp>
       <p:sp>
         <p:nvSpPr>
@@ -14950,6 +15342,10 @@
           </a:solidFill>
           <a:ln/>
         </p:spPr>
+        <p:txBody>
+          <a:bodyPr/>
+          <a:p/>
+        </p:txBody>
       </p:sp>
       <p:sp>
         <p:nvSpPr>
@@ -15042,6 +15438,10 @@
             <a:prstDash val="solid"/>
           </a:ln>
         </p:spPr>
+        <p:txBody>
+          <a:bodyPr/>
+          <a:p/>
+        </p:txBody>
       </p:sp>
       <p:sp>
         <p:nvSpPr>
@@ -15196,6 +15596,10 @@
           </a:solidFill>
           <a:ln/>
         </p:spPr>
+        <p:txBody>
+          <a:bodyPr/>
+          <a:p/>
+        </p:txBody>
       </p:sp>
       <p:sp>
         <p:nvSpPr>
@@ -15321,6 +15725,10 @@
           </a:gradFill>
           <a:ln/>
         </p:spPr>
+        <p:txBody>
+          <a:bodyPr/>
+          <a:p/>
+        </p:txBody>
       </p:sp>
       <p:sp>
         <p:nvSpPr>
@@ -15454,6 +15862,10 @@
             <a:prstDash val="solid"/>
           </a:ln>
         </p:spPr>
+        <p:txBody>
+          <a:bodyPr/>
+          <a:p/>
+        </p:txBody>
       </p:sp>
       <p:sp>
         <p:nvSpPr>
@@ -15539,6 +15951,10 @@
           </a:solidFill>
           <a:ln/>
         </p:spPr>
+        <p:txBody>
+          <a:bodyPr/>
+          <a:p/>
+        </p:txBody>
       </p:sp>
       <p:sp>
         <p:nvSpPr>
@@ -15644,6 +16060,10 @@
           </a:solidFill>
           <a:ln/>
         </p:spPr>
+        <p:txBody>
+          <a:bodyPr/>
+          <a:p/>
+        </p:txBody>
       </p:sp>
       <p:sp>
         <p:nvSpPr>
@@ -15749,6 +16169,10 @@
           </a:solidFill>
           <a:ln/>
         </p:spPr>
+        <p:txBody>
+          <a:bodyPr/>
+          <a:p/>
+        </p:txBody>
       </p:sp>
       <p:sp>
         <p:nvSpPr>
@@ -15854,6 +16278,10 @@
           </a:solidFill>
           <a:ln/>
         </p:spPr>
+        <p:txBody>
+          <a:bodyPr/>
+          <a:p/>
+        </p:txBody>
       </p:sp>
       <p:sp>
         <p:nvSpPr>
@@ -15959,6 +16387,10 @@
           </a:solidFill>
           <a:ln/>
         </p:spPr>
+        <p:txBody>
+          <a:bodyPr/>
+          <a:p/>
+        </p:txBody>
       </p:sp>
       <p:sp>
         <p:nvSpPr>
@@ -16095,6 +16527,10 @@
           </a:solidFill>
           <a:ln/>
         </p:spPr>
+        <p:txBody>
+          <a:bodyPr/>
+          <a:p/>
+        </p:txBody>
       </p:sp>
       <p:sp>
         <p:nvSpPr>
@@ -16164,7 +16600,7 @@
               </a:lnSpc>
             </a:pPr>
             <a:r>
-              <a:rPr lang="en-US" sz="2250" b="1" dirty="0">
+              <a:rPr lang="en-US" sz="3600" b="1" dirty="0">
                 <a:solidFill>
                   <a:srgbClr val="FFFFFF"/>
                 </a:solidFill>
@@ -16221,6 +16657,10 @@
           </a:solidFill>
           <a:ln/>
         </p:spPr>
+        <p:txBody>
+          <a:bodyPr/>
+          <a:p/>
+        </p:txBody>
       </p:sp>
       <p:sp>
         <p:nvSpPr>
@@ -16413,6 +16853,10 @@
             <a:prstDash val="solid"/>
           </a:ln>
         </p:spPr>
+        <p:txBody>
+          <a:bodyPr/>
+          <a:p/>
+        </p:txBody>
       </p:sp>
       <p:sp>
         <p:nvSpPr>
@@ -16498,6 +16942,10 @@
           </a:solidFill>
           <a:ln/>
         </p:spPr>
+        <p:txBody>
+          <a:bodyPr/>
+          <a:p/>
+        </p:txBody>
       </p:sp>
       <p:sp>
         <p:nvSpPr>
@@ -16542,6 +16990,10 @@
           </a:solidFill>
           <a:ln/>
         </p:spPr>
+        <p:txBody>
+          <a:bodyPr/>
+          <a:p/>
+        </p:txBody>
       </p:sp>
       <p:sp>
         <p:nvSpPr>
@@ -16712,6 +17164,10 @@
           </a:solidFill>
           <a:ln/>
         </p:spPr>
+        <p:txBody>
+          <a:bodyPr/>
+          <a:p/>
+        </p:txBody>
       </p:sp>
       <p:sp>
         <p:nvSpPr>
@@ -16840,6 +17296,10 @@
           </a:solidFill>
           <a:ln/>
         </p:spPr>
+        <p:txBody>
+          <a:bodyPr/>
+          <a:p/>
+        </p:txBody>
       </p:sp>
       <p:sp>
         <p:nvSpPr>
@@ -16884,6 +17344,10 @@
           </a:solidFill>
           <a:ln/>
         </p:spPr>
+        <p:txBody>
+          <a:bodyPr/>
+          <a:p/>
+        </p:txBody>
       </p:sp>
       <p:sp>
         <p:nvSpPr>
@@ -17039,6 +17503,10 @@
           </a:solidFill>
           <a:ln/>
         </p:spPr>
+        <p:txBody>
+          <a:bodyPr/>
+          <a:p/>
+        </p:txBody>
       </p:sp>
       <p:sp>
         <p:nvSpPr>
@@ -17167,6 +17635,10 @@
           </a:solidFill>
           <a:ln/>
         </p:spPr>
+        <p:txBody>
+          <a:bodyPr/>
+          <a:p/>
+        </p:txBody>
       </p:sp>
       <p:sp>
         <p:nvSpPr>
@@ -17211,6 +17683,10 @@
           </a:solidFill>
           <a:ln/>
         </p:spPr>
+        <p:txBody>
+          <a:bodyPr/>
+          <a:p/>
+        </p:txBody>
       </p:sp>
       <p:sp>
         <p:nvSpPr>
@@ -17302,6 +17778,10 @@
           </a:solidFill>
           <a:ln/>
         </p:spPr>
+        <p:txBody>
+          <a:bodyPr/>
+          <a:p/>
+        </p:txBody>
       </p:sp>
       <p:sp>
         <p:nvSpPr>
@@ -17430,6 +17910,10 @@
           </a:solidFill>
           <a:ln/>
         </p:spPr>
+        <p:txBody>
+          <a:bodyPr/>
+          <a:p/>
+        </p:txBody>
       </p:sp>
       <p:sp>
         <p:nvSpPr>
@@ -17474,6 +17958,10 @@
           </a:solidFill>
           <a:ln/>
         </p:spPr>
+        <p:txBody>
+          <a:bodyPr/>
+          <a:p/>
+        </p:txBody>
       </p:sp>
       <p:sp>
         <p:nvSpPr>
@@ -17755,6 +18243,10 @@
           </a:solidFill>
           <a:ln/>
         </p:spPr>
+        <p:txBody>
+          <a:bodyPr/>
+          <a:p/>
+        </p:txBody>
       </p:sp>
       <p:sp>
         <p:nvSpPr>
@@ -17883,6 +18375,10 @@
           </a:solidFill>
           <a:ln/>
         </p:spPr>
+        <p:txBody>
+          <a:bodyPr/>
+          <a:p/>
+        </p:txBody>
       </p:sp>
       <p:sp>
         <p:nvSpPr>
@@ -17927,6 +18423,10 @@
           </a:solidFill>
           <a:ln/>
         </p:spPr>
+        <p:txBody>
+          <a:bodyPr/>
+          <a:p/>
+        </p:txBody>
       </p:sp>
       <p:sp>
         <p:nvSpPr>
@@ -18027,6 +18527,10 @@
           </a:solidFill>
           <a:ln/>
         </p:spPr>
+        <p:txBody>
+          <a:bodyPr/>
+          <a:p/>
+        </p:txBody>
       </p:sp>
       <p:sp>
         <p:nvSpPr>
@@ -18162,6 +18666,10 @@
             <a:prstDash val="solid"/>
           </a:ln>
         </p:spPr>
+        <p:txBody>
+          <a:bodyPr/>
+          <a:p/>
+        </p:txBody>
       </p:sp>
       <p:sp>
         <p:nvSpPr>
@@ -18254,6 +18762,10 @@
             <a:prstDash val="solid"/>
           </a:ln>
         </p:spPr>
+        <p:txBody>
+          <a:bodyPr/>
+          <a:p/>
+        </p:txBody>
       </p:sp>
       <p:sp>
         <p:nvSpPr>
@@ -18450,6 +18962,10 @@
           </a:solidFill>
           <a:ln/>
         </p:spPr>
+        <p:txBody>
+          <a:bodyPr/>
+          <a:p/>
+        </p:txBody>
       </p:sp>
       <p:sp>
         <p:nvSpPr>
@@ -18585,6 +19101,10 @@
             <a:prstDash val="solid"/>
           </a:ln>
         </p:spPr>
+        <p:txBody>
+          <a:bodyPr/>
+          <a:p/>
+        </p:txBody>
       </p:sp>
       <p:sp>
         <p:nvSpPr>
@@ -18690,6 +19210,10 @@
           </a:solidFill>
           <a:ln/>
         </p:spPr>
+        <p:txBody>
+          <a:bodyPr/>
+          <a:p/>
+        </p:txBody>
       </p:sp>
       <p:sp>
         <p:nvSpPr>
@@ -18825,6 +19349,10 @@
             <a:prstDash val="solid"/>
           </a:ln>
         </p:spPr>
+        <p:txBody>
+          <a:bodyPr/>
+          <a:p/>
+        </p:txBody>
       </p:sp>
       <p:sp>
         <p:nvSpPr>
@@ -19011,6 +19539,10 @@
           </a:solidFill>
           <a:ln/>
         </p:spPr>
+        <p:txBody>
+          <a:bodyPr/>
+          <a:p/>
+        </p:txBody>
       </p:sp>
       <p:sp>
         <p:nvSpPr>
@@ -19146,6 +19678,10 @@
             <a:prstDash val="solid"/>
           </a:ln>
         </p:spPr>
+        <p:txBody>
+          <a:bodyPr/>
+          <a:p/>
+        </p:txBody>
       </p:sp>
       <p:sp>
         <p:nvSpPr>
@@ -19256,6 +19792,10 @@
           </a:solidFill>
           <a:ln/>
         </p:spPr>
+        <p:txBody>
+          <a:bodyPr/>
+          <a:p/>
+        </p:txBody>
       </p:sp>
       <p:sp>
         <p:nvSpPr>
@@ -19384,6 +19924,10 @@
           </a:solidFill>
           <a:ln/>
         </p:spPr>
+        <p:txBody>
+          <a:bodyPr/>
+          <a:p/>
+        </p:txBody>
       </p:sp>
       <p:sp>
         <p:nvSpPr>
@@ -19576,6 +20120,10 @@
             <a:prstDash val="solid"/>
           </a:ln>
         </p:spPr>
+        <p:txBody>
+          <a:bodyPr/>
+          <a:p/>
+        </p:txBody>
       </p:sp>
       <p:sp>
         <p:nvSpPr>
@@ -19711,6 +20259,10 @@
             <a:prstDash val="solid"/>
           </a:ln>
         </p:spPr>
+        <p:txBody>
+          <a:bodyPr/>
+          <a:p/>
+        </p:txBody>
       </p:sp>
       <p:sp>
         <p:nvSpPr>
@@ -19846,6 +20398,10 @@
             <a:prstDash val="solid"/>
           </a:ln>
         </p:spPr>
+        <p:txBody>
+          <a:bodyPr/>
+          <a:p/>
+        </p:txBody>
       </p:sp>
       <p:sp>
         <p:nvSpPr>
@@ -20048,6 +20604,10 @@
           </a:gradFill>
           <a:ln/>
         </p:spPr>
+        <p:txBody>
+          <a:bodyPr/>
+          <a:p/>
+        </p:txBody>
       </p:sp>
       <p:sp>
         <p:nvSpPr>
@@ -20099,6 +20659,10 @@
             <a:prstDash val="solid"/>
           </a:ln>
         </p:spPr>
+        <p:txBody>
+          <a:bodyPr/>
+          <a:p/>
+        </p:txBody>
       </p:sp>
       <p:sp>
         <p:nvSpPr>
@@ -20143,6 +20707,10 @@
           </a:solidFill>
           <a:ln/>
         </p:spPr>
+        <p:txBody>
+          <a:bodyPr/>
+          <a:p/>
+        </p:txBody>
       </p:sp>
       <p:sp>
         <p:nvSpPr>
@@ -20228,6 +20796,10 @@
           </a:solidFill>
           <a:ln/>
         </p:spPr>
+        <p:txBody>
+          <a:bodyPr/>
+          <a:p/>
+        </p:txBody>
       </p:sp>
       <p:sp>
         <p:nvSpPr>
@@ -20297,7 +20869,7 @@
               </a:lnSpc>
             </a:pPr>
             <a:r>
-              <a:rPr lang="en-US" sz="5400" b="1" dirty="0">
+              <a:rPr lang="en-US" sz="3600" b="1" dirty="0">
                 <a:solidFill>
                   <a:srgbClr val="FFFFFF"/>
                 </a:solidFill>
@@ -20316,7 +20888,7 @@
               </a:lnSpc>
             </a:pPr>
             <a:r>
-              <a:rPr lang="en-US" sz="5400" b="1" dirty="0">
+              <a:rPr lang="en-US" sz="3600" b="1" dirty="0">
                 <a:solidFill>
                   <a:srgbClr val="DDFF00"/>
                 </a:solidFill>
@@ -20416,6 +20988,10 @@
           </a:solidFill>
           <a:ln/>
         </p:spPr>
+        <p:txBody>
+          <a:bodyPr/>
+          <a:p/>
+        </p:txBody>
       </p:sp>
       <p:sp>
         <p:nvSpPr>
@@ -20460,6 +21036,10 @@
           </a:solidFill>
           <a:ln/>
         </p:spPr>
+        <p:txBody>
+          <a:bodyPr/>
+          <a:p/>
+        </p:txBody>
       </p:sp>
       <p:sp>
         <p:nvSpPr>
@@ -20504,6 +21084,10 @@
           </a:solidFill>
           <a:ln/>
         </p:spPr>
+        <p:txBody>
+          <a:bodyPr/>
+          <a:p/>
+        </p:txBody>
       </p:sp>
     </p:spTree>
   </p:cSld>
@@ -20580,6 +21164,10 @@
           </a:solidFill>
           <a:ln/>
         </p:spPr>
+        <p:txBody>
+          <a:bodyPr/>
+          <a:p/>
+        </p:txBody>
       </p:sp>
       <p:sp>
         <p:nvSpPr>
@@ -20649,7 +21237,7 @@
               </a:lnSpc>
             </a:pPr>
             <a:r>
-              <a:rPr lang="en-US" sz="2298" b="1" dirty="0">
+              <a:rPr lang="en-US" sz="3600" b="1" dirty="0">
                 <a:solidFill>
                   <a:srgbClr val="FFFFFF"/>
                 </a:solidFill>
@@ -20706,6 +21294,10 @@
           </a:solidFill>
           <a:ln/>
         </p:spPr>
+        <p:txBody>
+          <a:bodyPr/>
+          <a:p/>
+        </p:txBody>
       </p:sp>
       <p:sp>
         <p:nvSpPr>
@@ -20898,6 +21490,10 @@
             <a:prstDash val="solid"/>
           </a:ln>
         </p:spPr>
+        <p:txBody>
+          <a:bodyPr/>
+          <a:p/>
+        </p:txBody>
       </p:sp>
       <p:sp>
         <p:nvSpPr>
@@ -20983,6 +21579,10 @@
           </a:solidFill>
           <a:ln/>
         </p:spPr>
+        <p:txBody>
+          <a:bodyPr/>
+          <a:p/>
+        </p:txBody>
       </p:sp>
       <p:sp>
         <p:nvSpPr>
@@ -21154,6 +21754,10 @@
           </a:solidFill>
           <a:ln/>
         </p:spPr>
+        <p:txBody>
+          <a:bodyPr/>
+          <a:p/>
+        </p:txBody>
       </p:sp>
       <p:sp>
         <p:nvSpPr>
@@ -21325,6 +21929,10 @@
           </a:solidFill>
           <a:ln/>
         </p:spPr>
+        <p:txBody>
+          <a:bodyPr/>
+          <a:p/>
+        </p:txBody>
       </p:sp>
       <p:sp>
         <p:nvSpPr>
@@ -21496,6 +22104,10 @@
           </a:solidFill>
           <a:ln/>
         </p:spPr>
+        <p:txBody>
+          <a:bodyPr/>
+          <a:p/>
+        </p:txBody>
       </p:sp>
       <p:sp>
         <p:nvSpPr>
@@ -21674,6 +22286,10 @@
             <a:prstDash val="solid"/>
           </a:ln>
         </p:spPr>
+        <p:txBody>
+          <a:bodyPr/>
+          <a:p/>
+        </p:txBody>
       </p:sp>
       <p:sp>
         <p:nvSpPr>
@@ -21759,6 +22375,10 @@
           </a:solidFill>
           <a:ln/>
         </p:spPr>
+        <p:txBody>
+          <a:bodyPr/>
+          <a:p/>
+        </p:txBody>
       </p:sp>
       <p:sp>
         <p:nvSpPr>
@@ -21851,6 +22471,10 @@
             <a:prstDash val="solid"/>
           </a:ln>
         </p:spPr>
+        <p:txBody>
+          <a:bodyPr/>
+          <a:p/>
+        </p:txBody>
       </p:sp>
       <p:sp>
         <p:nvSpPr>
@@ -21972,6 +22596,10 @@
           </a:solidFill>
           <a:ln/>
         </p:spPr>
+        <p:txBody>
+          <a:bodyPr/>
+          <a:p/>
+        </p:txBody>
       </p:sp>
       <p:sp>
         <p:nvSpPr>
@@ -22064,6 +22692,10 @@
             <a:prstDash val="solid"/>
           </a:ln>
         </p:spPr>
+        <p:txBody>
+          <a:bodyPr/>
+          <a:p/>
+        </p:txBody>
       </p:sp>
       <p:sp>
         <p:nvSpPr>
@@ -22179,6 +22811,10 @@
           </a:solidFill>
           <a:ln/>
         </p:spPr>
+        <p:txBody>
+          <a:bodyPr/>
+          <a:p/>
+        </p:txBody>
       </p:sp>
       <p:sp>
         <p:nvSpPr>
@@ -22271,6 +22907,10 @@
             <a:prstDash val="solid"/>
           </a:ln>
         </p:spPr>
+        <p:txBody>
+          <a:bodyPr/>
+          <a:p/>
+        </p:txBody>
       </p:sp>
       <p:sp>
         <p:nvSpPr>
@@ -22425,6 +23065,10 @@
           </a:solidFill>
           <a:ln/>
         </p:spPr>
+        <p:txBody>
+          <a:bodyPr/>
+          <a:p/>
+        </p:txBody>
       </p:sp>
       <p:sp>
         <p:nvSpPr>
@@ -22550,6 +23194,10 @@
           </a:gradFill>
           <a:ln/>
         </p:spPr>
+        <p:txBody>
+          <a:bodyPr/>
+          <a:p/>
+        </p:txBody>
       </p:sp>
       <p:sp>
         <p:nvSpPr>
@@ -22683,6 +23331,10 @@
             <a:prstDash val="solid"/>
           </a:ln>
         </p:spPr>
+        <p:txBody>
+          <a:bodyPr/>
+          <a:p/>
+        </p:txBody>
       </p:sp>
       <p:sp>
         <p:nvSpPr>
@@ -22868,6 +23520,10 @@
           </a:solidFill>
           <a:ln/>
         </p:spPr>
+        <p:txBody>
+          <a:bodyPr/>
+          <a:p/>
+        </p:txBody>
       </p:sp>
       <p:sp>
         <p:nvSpPr>
@@ -23004,6 +23660,10 @@
           </a:solidFill>
           <a:ln/>
         </p:spPr>
+        <p:txBody>
+          <a:bodyPr/>
+          <a:p/>
+        </p:txBody>
       </p:sp>
       <p:sp>
         <p:nvSpPr>
@@ -23073,7 +23733,7 @@
               </a:lnSpc>
             </a:pPr>
             <a:r>
-              <a:rPr lang="en-US" sz="2250" b="1" dirty="0">
+              <a:rPr lang="en-US" sz="3600" b="1" dirty="0">
                 <a:solidFill>
                   <a:srgbClr val="FFFFFF"/>
                 </a:solidFill>
@@ -23130,6 +23790,10 @@
           </a:solidFill>
           <a:ln/>
         </p:spPr>
+        <p:txBody>
+          <a:bodyPr/>
+          <a:p/>
+        </p:txBody>
       </p:sp>
       <p:sp>
         <p:nvSpPr>
@@ -23322,6 +23986,10 @@
             <a:prstDash val="solid"/>
           </a:ln>
         </p:spPr>
+        <p:txBody>
+          <a:bodyPr/>
+          <a:p/>
+        </p:txBody>
       </p:sp>
       <p:sp>
         <p:nvSpPr>
@@ -23407,6 +24075,10 @@
           </a:solidFill>
           <a:ln/>
         </p:spPr>
+        <p:txBody>
+          <a:bodyPr/>
+          <a:p/>
+        </p:txBody>
       </p:sp>
       <p:sp>
         <p:nvSpPr>
@@ -23451,6 +24123,10 @@
           </a:solidFill>
           <a:ln/>
         </p:spPr>
+        <p:txBody>
+          <a:bodyPr/>
+          <a:p/>
+        </p:txBody>
       </p:sp>
       <p:sp>
         <p:nvSpPr>
@@ -23735,6 +24411,10 @@
           </a:solidFill>
           <a:ln/>
         </p:spPr>
+        <p:txBody>
+          <a:bodyPr/>
+          <a:p/>
+        </p:txBody>
       </p:sp>
       <p:sp>
         <p:nvSpPr>
@@ -23863,6 +24543,10 @@
           </a:solidFill>
           <a:ln/>
         </p:spPr>
+        <p:txBody>
+          <a:bodyPr/>
+          <a:p/>
+        </p:txBody>
       </p:sp>
       <p:sp>
         <p:nvSpPr>
@@ -23907,6 +24591,10 @@
           </a:solidFill>
           <a:ln/>
         </p:spPr>
+        <p:txBody>
+          <a:bodyPr/>
+          <a:p/>
+        </p:txBody>
       </p:sp>
       <p:sp>
         <p:nvSpPr>
@@ -24125,6 +24813,10 @@
           </a:solidFill>
           <a:ln/>
         </p:spPr>
+        <p:txBody>
+          <a:bodyPr/>
+          <a:p/>
+        </p:txBody>
       </p:sp>
       <p:sp>
         <p:nvSpPr>
@@ -24253,6 +24945,10 @@
           </a:solidFill>
           <a:ln/>
         </p:spPr>
+        <p:txBody>
+          <a:bodyPr/>
+          <a:p/>
+        </p:txBody>
       </p:sp>
       <p:sp>
         <p:nvSpPr>
@@ -24297,6 +24993,10 @@
           </a:solidFill>
           <a:ln/>
         </p:spPr>
+        <p:txBody>
+          <a:bodyPr/>
+          <a:p/>
+        </p:txBody>
       </p:sp>
       <p:sp>
         <p:nvSpPr>
@@ -24451,6 +25151,10 @@
           </a:solidFill>
           <a:ln/>
         </p:spPr>
+        <p:txBody>
+          <a:bodyPr/>
+          <a:p/>
+        </p:txBody>
       </p:sp>
       <p:sp>
         <p:nvSpPr>
@@ -24579,6 +25283,10 @@
           </a:solidFill>
           <a:ln/>
         </p:spPr>
+        <p:txBody>
+          <a:bodyPr/>
+          <a:p/>
+        </p:txBody>
       </p:sp>
       <p:sp>
         <p:nvSpPr>
@@ -24623,6 +25331,10 @@
           </a:solidFill>
           <a:ln/>
         </p:spPr>
+        <p:txBody>
+          <a:bodyPr/>
+          <a:p/>
+        </p:txBody>
       </p:sp>
       <p:sp>
         <p:nvSpPr>
@@ -24710,6 +25422,10 @@
           </a:solidFill>
           <a:ln/>
         </p:spPr>
+        <p:txBody>
+          <a:bodyPr/>
+          <a:p/>
+        </p:txBody>
       </p:sp>
       <p:sp>
         <p:nvSpPr>
@@ -24838,6 +25554,10 @@
           </a:solidFill>
           <a:ln/>
         </p:spPr>
+        <p:txBody>
+          <a:bodyPr/>
+          <a:p/>
+        </p:txBody>
       </p:sp>
       <p:sp>
         <p:nvSpPr>
@@ -24882,6 +25602,10 @@
           </a:solidFill>
           <a:ln/>
         </p:spPr>
+        <p:txBody>
+          <a:bodyPr/>
+          <a:p/>
+        </p:txBody>
       </p:sp>
       <p:sp>
         <p:nvSpPr>
@@ -25037,6 +25761,10 @@
           </a:solidFill>
           <a:ln/>
         </p:spPr>
+        <p:txBody>
+          <a:bodyPr/>
+          <a:p/>
+        </p:txBody>
       </p:sp>
       <p:sp>
         <p:nvSpPr>
@@ -25172,6 +25900,10 @@
             <a:prstDash val="solid"/>
           </a:ln>
         </p:spPr>
+        <p:txBody>
+          <a:bodyPr/>
+          <a:p/>
+        </p:txBody>
       </p:sp>
       <p:sp>
         <p:nvSpPr>
@@ -25264,6 +25996,10 @@
             <a:prstDash val="solid"/>
           </a:ln>
         </p:spPr>
+        <p:txBody>
+          <a:bodyPr/>
+          <a:p/>
+        </p:txBody>
       </p:sp>
       <p:sp>
         <p:nvSpPr>
@@ -25442,6 +26178,10 @@
             <a:prstDash val="solid"/>
           </a:ln>
         </p:spPr>
+        <p:txBody>
+          <a:bodyPr/>
+          <a:p/>
+        </p:txBody>
       </p:sp>
       <p:sp>
         <p:nvSpPr>
@@ -25620,6 +26360,10 @@
             <a:prstDash val="solid"/>
           </a:ln>
         </p:spPr>
+        <p:txBody>
+          <a:bodyPr/>
+          <a:p/>
+        </p:txBody>
       </p:sp>
       <p:sp>
         <p:nvSpPr>
@@ -25798,6 +26542,10 @@
             <a:prstDash val="solid"/>
           </a:ln>
         </p:spPr>
+        <p:txBody>
+          <a:bodyPr/>
+          <a:p/>
+        </p:txBody>
       </p:sp>
       <p:sp>
         <p:nvSpPr>
@@ -25969,6 +26717,10 @@
           </a:solidFill>
           <a:ln/>
         </p:spPr>
+        <p:txBody>
+          <a:bodyPr/>
+          <a:p/>
+        </p:txBody>
       </p:sp>
       <p:sp>
         <p:nvSpPr>
@@ -26161,6 +26913,10 @@
             <a:prstDash val="solid"/>
           </a:ln>
         </p:spPr>
+        <p:txBody>
+          <a:bodyPr/>
+          <a:p/>
+        </p:txBody>
       </p:sp>
       <p:sp>
         <p:nvSpPr>
@@ -26296,6 +27052,10 @@
             <a:prstDash val="solid"/>
           </a:ln>
         </p:spPr>
+        <p:txBody>
+          <a:bodyPr/>
+          <a:p/>
+        </p:txBody>
       </p:sp>
       <p:sp>
         <p:nvSpPr>
@@ -26431,6 +27191,10 @@
             <a:prstDash val="solid"/>
           </a:ln>
         </p:spPr>
+        <p:txBody>
+          <a:bodyPr/>
+          <a:p/>
+        </p:txBody>
       </p:sp>
       <p:sp>
         <p:nvSpPr>
@@ -26591,6 +27355,10 @@
           </a:solidFill>
           <a:ln/>
         </p:spPr>
+        <p:txBody>
+          <a:bodyPr/>
+          <a:p/>
+        </p:txBody>
       </p:sp>
       <p:sp>
         <p:nvSpPr>
@@ -26717,6 +27485,10 @@
           </a:solidFill>
           <a:ln/>
         </p:spPr>
+        <p:txBody>
+          <a:bodyPr/>
+          <a:p/>
+        </p:txBody>
       </p:sp>
       <p:sp>
         <p:nvSpPr>
@@ -26886,6 +27658,10 @@
           </a:solidFill>
           <a:ln/>
         </p:spPr>
+        <p:txBody>
+          <a:bodyPr/>
+          <a:p/>
+        </p:txBody>
       </p:sp>
       <p:sp>
         <p:nvSpPr>
@@ -27055,6 +27831,10 @@
           </a:solidFill>
           <a:ln/>
         </p:spPr>
+        <p:txBody>
+          <a:bodyPr/>
+          <a:p/>
+        </p:txBody>
       </p:sp>
       <p:sp>
         <p:nvSpPr>
@@ -27224,6 +28004,10 @@
           </a:solidFill>
           <a:ln/>
         </p:spPr>
+        <p:txBody>
+          <a:bodyPr/>
+          <a:p/>
+        </p:txBody>
       </p:sp>
       <p:sp>
         <p:nvSpPr>
@@ -27393,6 +28177,10 @@
           </a:solidFill>
           <a:ln/>
         </p:spPr>
+        <p:txBody>
+          <a:bodyPr/>
+          <a:p/>
+        </p:txBody>
       </p:sp>
       <p:sp>
         <p:nvSpPr>
@@ -27562,6 +28350,10 @@
           </a:solidFill>
           <a:ln/>
         </p:spPr>
+        <p:txBody>
+          <a:bodyPr/>
+          <a:p/>
+        </p:txBody>
       </p:sp>
       <p:sp>
         <p:nvSpPr>
@@ -27731,6 +28523,10 @@
           </a:solidFill>
           <a:ln/>
         </p:spPr>
+        <p:txBody>
+          <a:bodyPr/>
+          <a:p/>
+        </p:txBody>
       </p:sp>
       <p:sp>
         <p:nvSpPr>
@@ -27900,6 +28696,10 @@
           </a:solidFill>
           <a:ln/>
         </p:spPr>
+        <p:txBody>
+          <a:bodyPr/>
+          <a:p/>
+        </p:txBody>
       </p:sp>
       <p:sp>
         <p:nvSpPr>
@@ -28069,6 +28869,10 @@
           </a:solidFill>
           <a:ln/>
         </p:spPr>
+        <p:txBody>
+          <a:bodyPr/>
+          <a:p/>
+        </p:txBody>
       </p:sp>
       <p:sp>
         <p:nvSpPr>
@@ -28113,6 +28917,10 @@
           </a:solidFill>
           <a:ln/>
         </p:spPr>
+        <p:txBody>
+          <a:bodyPr/>
+          <a:p/>
+        </p:txBody>
       </p:sp>
       <p:sp>
         <p:nvSpPr>
@@ -28157,6 +28965,10 @@
           </a:solidFill>
           <a:ln/>
         </p:spPr>
+        <p:txBody>
+          <a:bodyPr/>
+          <a:p/>
+        </p:txBody>
       </p:sp>
     </p:spTree>
   </p:cSld>
@@ -28275,6 +29087,10 @@
           </a:gradFill>
           <a:ln/>
         </p:spPr>
+        <p:txBody>
+          <a:bodyPr/>
+          <a:p/>
+        </p:txBody>
       </p:sp>
       <p:sp>
         <p:nvSpPr>
@@ -28326,6 +29142,10 @@
             <a:prstDash val="solid"/>
           </a:ln>
         </p:spPr>
+        <p:txBody>
+          <a:bodyPr/>
+          <a:p/>
+        </p:txBody>
       </p:sp>
       <p:sp>
         <p:nvSpPr>
@@ -28370,6 +29190,10 @@
           </a:solidFill>
           <a:ln/>
         </p:spPr>
+        <p:txBody>
+          <a:bodyPr/>
+          <a:p/>
+        </p:txBody>
       </p:sp>
       <p:sp>
         <p:nvSpPr>
@@ -28455,6 +29279,10 @@
           </a:solidFill>
           <a:ln/>
         </p:spPr>
+        <p:txBody>
+          <a:bodyPr/>
+          <a:p/>
+        </p:txBody>
       </p:sp>
       <p:sp>
         <p:nvSpPr>
@@ -28524,7 +29352,7 @@
               </a:lnSpc>
             </a:pPr>
             <a:r>
-              <a:rPr lang="en-US" sz="5400" b="1" dirty="0">
+              <a:rPr lang="en-US" sz="3600" b="1" dirty="0">
                 <a:solidFill>
                   <a:srgbClr val="FFFFFF"/>
                 </a:solidFill>
@@ -28543,7 +29371,7 @@
               </a:lnSpc>
             </a:pPr>
             <a:r>
-              <a:rPr lang="en-US" sz="5400" b="1" dirty="0">
+              <a:rPr lang="en-US" sz="3600" b="1" dirty="0">
                 <a:solidFill>
                   <a:srgbClr val="DDFF00"/>
                 </a:solidFill>
@@ -28643,6 +29471,10 @@
           </a:solidFill>
           <a:ln/>
         </p:spPr>
+        <p:txBody>
+          <a:bodyPr/>
+          <a:p/>
+        </p:txBody>
       </p:sp>
       <p:sp>
         <p:nvSpPr>
@@ -28687,6 +29519,10 @@
           </a:solidFill>
           <a:ln/>
         </p:spPr>
+        <p:txBody>
+          <a:bodyPr/>
+          <a:p/>
+        </p:txBody>
       </p:sp>
       <p:sp>
         <p:nvSpPr>
@@ -28731,6 +29567,10 @@
           </a:solidFill>
           <a:ln/>
         </p:spPr>
+        <p:txBody>
+          <a:bodyPr/>
+          <a:p/>
+        </p:txBody>
       </p:sp>
     </p:spTree>
   </p:cSld>
@@ -28807,6 +29647,10 @@
           </a:solidFill>
           <a:ln/>
         </p:spPr>
+        <p:txBody>
+          <a:bodyPr/>
+          <a:p/>
+        </p:txBody>
       </p:sp>
       <p:sp>
         <p:nvSpPr>
@@ -28876,7 +29720,7 @@
               </a:lnSpc>
             </a:pPr>
             <a:r>
-              <a:rPr lang="en-US" sz="2281" b="1" dirty="0">
+              <a:rPr lang="en-US" sz="3600" b="1" dirty="0">
                 <a:solidFill>
                   <a:srgbClr val="FFFFFF"/>
                 </a:solidFill>
@@ -28933,6 +29777,10 @@
           </a:solidFill>
           <a:ln/>
         </p:spPr>
+        <p:txBody>
+          <a:bodyPr/>
+          <a:p/>
+        </p:txBody>
       </p:sp>
       <p:sp>
         <p:nvSpPr>
@@ -29125,6 +29973,10 @@
             <a:prstDash val="solid"/>
           </a:ln>
         </p:spPr>
+        <p:txBody>
+          <a:bodyPr/>
+          <a:p/>
+        </p:txBody>
       </p:sp>
       <p:sp>
         <p:nvSpPr>
@@ -29210,6 +30062,10 @@
           </a:solidFill>
           <a:ln/>
         </p:spPr>
+        <p:txBody>
+          <a:bodyPr/>
+          <a:p/>
+        </p:txBody>
       </p:sp>
       <p:sp>
         <p:nvSpPr>
@@ -29381,6 +30237,10 @@
           </a:solidFill>
           <a:ln/>
         </p:spPr>
+        <p:txBody>
+          <a:bodyPr/>
+          <a:p/>
+        </p:txBody>
       </p:sp>
       <p:sp>
         <p:nvSpPr>
@@ -29552,6 +30412,10 @@
           </a:solidFill>
           <a:ln/>
         </p:spPr>
+        <p:txBody>
+          <a:bodyPr/>
+          <a:p/>
+        </p:txBody>
       </p:sp>
       <p:sp>
         <p:nvSpPr>
@@ -29723,6 +30587,10 @@
           </a:solidFill>
           <a:ln/>
         </p:spPr>
+        <p:txBody>
+          <a:bodyPr/>
+          <a:p/>
+        </p:txBody>
       </p:sp>
       <p:sp>
         <p:nvSpPr>
@@ -29894,6 +30762,10 @@
           </a:solidFill>
           <a:ln/>
         </p:spPr>
+        <p:txBody>
+          <a:bodyPr/>
+          <a:p/>
+        </p:txBody>
       </p:sp>
       <p:sp>
         <p:nvSpPr>
@@ -30065,6 +30937,10 @@
           </a:solidFill>
           <a:ln/>
         </p:spPr>
+        <p:txBody>
+          <a:bodyPr/>
+          <a:p/>
+        </p:txBody>
       </p:sp>
       <p:sp>
         <p:nvSpPr>
@@ -30276,6 +31152,10 @@
           </a:gradFill>
           <a:ln/>
         </p:spPr>
+        <p:txBody>
+          <a:bodyPr/>
+          <a:p/>
+        </p:txBody>
       </p:sp>
       <p:sp>
         <p:nvSpPr>
@@ -30409,6 +31289,10 @@
             <a:prstDash val="solid"/>
           </a:ln>
         </p:spPr>
+        <p:txBody>
+          <a:bodyPr/>
+          <a:p/>
+        </p:txBody>
       </p:sp>
       <p:sp>
         <p:nvSpPr>
@@ -30494,6 +31378,10 @@
           </a:solidFill>
           <a:ln/>
         </p:spPr>
+        <p:txBody>
+          <a:bodyPr/>
+          <a:p/>
+        </p:txBody>
       </p:sp>
       <p:sp>
         <p:nvSpPr>
@@ -30599,6 +31487,10 @@
           </a:solidFill>
           <a:ln/>
         </p:spPr>
+        <p:txBody>
+          <a:bodyPr/>
+          <a:p/>
+        </p:txBody>
       </p:sp>
       <p:sp>
         <p:nvSpPr>
@@ -30704,6 +31596,10 @@
           </a:solidFill>
           <a:ln/>
         </p:spPr>
+        <p:txBody>
+          <a:bodyPr/>
+          <a:p/>
+        </p:txBody>
       </p:sp>
       <p:sp>
         <p:nvSpPr>
@@ -30809,6 +31705,10 @@
           </a:solidFill>
           <a:ln/>
         </p:spPr>
+        <p:txBody>
+          <a:bodyPr/>
+          <a:p/>
+        </p:txBody>
       </p:sp>
       <p:sp>
         <p:nvSpPr>
@@ -30914,6 +31814,10 @@
           </a:solidFill>
           <a:ln/>
         </p:spPr>
+        <p:txBody>
+          <a:bodyPr/>
+          <a:p/>
+        </p:txBody>
       </p:sp>
       <p:sp>
         <p:nvSpPr>
@@ -31114,6 +32018,10 @@
           </a:gradFill>
           <a:ln/>
         </p:spPr>
+        <p:txBody>
+          <a:bodyPr/>
+          <a:p/>
+        </p:txBody>
       </p:sp>
       <p:sp>
         <p:nvSpPr>
@@ -31165,6 +32073,10 @@
             <a:prstDash val="solid"/>
           </a:ln>
         </p:spPr>
+        <p:txBody>
+          <a:bodyPr/>
+          <a:p/>
+        </p:txBody>
       </p:sp>
       <p:sp>
         <p:nvSpPr>
@@ -31209,6 +32121,10 @@
           </a:solidFill>
           <a:ln/>
         </p:spPr>
+        <p:txBody>
+          <a:bodyPr/>
+          <a:p/>
+        </p:txBody>
       </p:sp>
       <p:sp>
         <p:nvSpPr>
@@ -31294,6 +32210,10 @@
           </a:solidFill>
           <a:ln/>
         </p:spPr>
+        <p:txBody>
+          <a:bodyPr/>
+          <a:p/>
+        </p:txBody>
       </p:sp>
       <p:sp>
         <p:nvSpPr>
@@ -31363,7 +32283,7 @@
               </a:lnSpc>
             </a:pPr>
             <a:r>
-              <a:rPr lang="en-US" sz="5400" b="1" dirty="0">
+              <a:rPr lang="en-US" sz="3600" b="1" dirty="0">
                 <a:solidFill>
                   <a:srgbClr val="FFFFFF"/>
                 </a:solidFill>
@@ -31382,7 +32302,7 @@
               </a:lnSpc>
             </a:pPr>
             <a:r>
-              <a:rPr lang="en-US" sz="5400" b="1" dirty="0">
+              <a:rPr lang="en-US" sz="3600" b="1" dirty="0">
                 <a:solidFill>
                   <a:srgbClr val="DDFF00"/>
                 </a:solidFill>
@@ -31482,6 +32402,10 @@
           </a:solidFill>
           <a:ln/>
         </p:spPr>
+        <p:txBody>
+          <a:bodyPr/>
+          <a:p/>
+        </p:txBody>
       </p:sp>
       <p:sp>
         <p:nvSpPr>
@@ -31526,6 +32450,10 @@
           </a:solidFill>
           <a:ln/>
         </p:spPr>
+        <p:txBody>
+          <a:bodyPr/>
+          <a:p/>
+        </p:txBody>
       </p:sp>
       <p:sp>
         <p:nvSpPr>
@@ -31570,6 +32498,10 @@
           </a:solidFill>
           <a:ln/>
         </p:spPr>
+        <p:txBody>
+          <a:bodyPr/>
+          <a:p/>
+        </p:txBody>
       </p:sp>
     </p:spTree>
   </p:cSld>
@@ -31646,6 +32578,10 @@
           </a:solidFill>
           <a:ln/>
         </p:spPr>
+        <p:txBody>
+          <a:bodyPr/>
+          <a:p/>
+        </p:txBody>
       </p:sp>
       <p:sp>
         <p:nvSpPr>
@@ -31715,7 +32651,7 @@
               </a:lnSpc>
             </a:pPr>
             <a:r>
-              <a:rPr lang="en-US" sz="2250" b="1" dirty="0">
+              <a:rPr lang="en-US" sz="3600" b="1" dirty="0">
                 <a:solidFill>
                   <a:srgbClr val="FFFFFF"/>
                 </a:solidFill>
@@ -31772,6 +32708,10 @@
           </a:solidFill>
           <a:ln/>
         </p:spPr>
+        <p:txBody>
+          <a:bodyPr/>
+          <a:p/>
+        </p:txBody>
       </p:sp>
       <p:sp>
         <p:nvSpPr>
@@ -31964,6 +32904,10 @@
             <a:prstDash val="solid"/>
           </a:ln>
         </p:spPr>
+        <p:txBody>
+          <a:bodyPr/>
+          <a:p/>
+        </p:txBody>
       </p:sp>
       <p:sp>
         <p:nvSpPr>
@@ -32056,6 +33000,10 @@
             <a:prstDash val="solid"/>
           </a:ln>
         </p:spPr>
+        <p:txBody>
+          <a:bodyPr/>
+          <a:p/>
+        </p:txBody>
       </p:sp>
       <p:sp>
         <p:nvSpPr>
@@ -32171,6 +33119,10 @@
           </a:solidFill>
           <a:ln/>
         </p:spPr>
+        <p:txBody>
+          <a:bodyPr/>
+          <a:p/>
+        </p:txBody>
       </p:sp>
       <p:sp>
         <p:nvSpPr>
@@ -32306,6 +33258,10 @@
             <a:prstDash val="solid"/>
           </a:ln>
         </p:spPr>
+        <p:txBody>
+          <a:bodyPr/>
+          <a:p/>
+        </p:txBody>
       </p:sp>
       <p:sp>
         <p:nvSpPr>
@@ -32515,6 +33471,10 @@
           </a:solidFill>
           <a:ln/>
         </p:spPr>
+        <p:txBody>
+          <a:bodyPr/>
+          <a:p/>
+        </p:txBody>
       </p:sp>
       <p:sp>
         <p:nvSpPr>
@@ -32650,6 +33610,10 @@
             <a:prstDash val="solid"/>
           </a:ln>
         </p:spPr>
+        <p:txBody>
+          <a:bodyPr/>
+          <a:p/>
+        </p:txBody>
       </p:sp>
       <p:sp>
         <p:nvSpPr>
@@ -32893,6 +33857,10 @@
           </a:solidFill>
           <a:ln/>
         </p:spPr>
+        <p:txBody>
+          <a:bodyPr/>
+          <a:p/>
+        </p:txBody>
       </p:sp>
       <p:sp>
         <p:nvSpPr>
@@ -33028,6 +33996,10 @@
             <a:prstDash val="solid"/>
           </a:ln>
         </p:spPr>
+        <p:txBody>
+          <a:bodyPr/>
+          <a:p/>
+        </p:txBody>
       </p:sp>
       <p:sp>
         <p:nvSpPr>
@@ -33198,6 +34170,10 @@
           </a:solidFill>
           <a:ln/>
         </p:spPr>
+        <p:txBody>
+          <a:bodyPr/>
+          <a:p/>
+        </p:txBody>
       </p:sp>
       <p:sp>
         <p:nvSpPr>
@@ -33333,6 +34309,10 @@
             <a:prstDash val="solid"/>
           </a:ln>
         </p:spPr>
+        <p:txBody>
+          <a:bodyPr/>
+          <a:p/>
+        </p:txBody>
       </p:sp>
       <p:sp>
         <p:nvSpPr>
@@ -33438,6 +34418,10 @@
           </a:solidFill>
           <a:ln/>
         </p:spPr>
+        <p:txBody>
+          <a:bodyPr/>
+          <a:p/>
+        </p:txBody>
       </p:sp>
       <p:sp>
         <p:nvSpPr>
@@ -33530,6 +34514,10 @@
             <a:prstDash val="solid"/>
           </a:ln>
         </p:spPr>
+        <p:txBody>
+          <a:bodyPr/>
+          <a:p/>
+        </p:txBody>
       </p:sp>
       <p:sp>
         <p:nvSpPr>
@@ -33760,6 +34748,10 @@
           </a:solidFill>
           <a:ln/>
         </p:spPr>
+        <p:txBody>
+          <a:bodyPr/>
+          <a:p/>
+        </p:txBody>
       </p:sp>
       <p:sp>
         <p:nvSpPr>
@@ -33852,6 +34844,10 @@
             <a:prstDash val="solid"/>
           </a:ln>
         </p:spPr>
+        <p:txBody>
+          <a:bodyPr/>
+          <a:p/>
+        </p:txBody>
       </p:sp>
       <p:sp>
         <p:nvSpPr>
@@ -33936,6 +34932,10 @@
           </a:solidFill>
           <a:ln/>
         </p:spPr>
+        <p:txBody>
+          <a:bodyPr/>
+          <a:p/>
+        </p:txBody>
       </p:sp>
       <p:sp>
         <p:nvSpPr>
@@ -34028,6 +35028,10 @@
             <a:prstDash val="solid"/>
           </a:ln>
         </p:spPr>
+        <p:txBody>
+          <a:bodyPr/>
+          <a:p/>
+        </p:txBody>
       </p:sp>
       <p:sp>
         <p:nvSpPr>
@@ -34172,6 +35176,10 @@
           </a:solidFill>
           <a:ln/>
         </p:spPr>
+        <p:txBody>
+          <a:bodyPr/>
+          <a:p/>
+        </p:txBody>
       </p:sp>
       <p:sp>
         <p:nvSpPr>
@@ -34297,6 +35305,10 @@
           </a:gradFill>
           <a:ln/>
         </p:spPr>
+        <p:txBody>
+          <a:bodyPr/>
+          <a:p/>
+        </p:txBody>
       </p:sp>
       <p:sp>
         <p:nvSpPr>
@@ -34430,6 +35442,10 @@
             <a:prstDash val="solid"/>
           </a:ln>
         </p:spPr>
+        <p:txBody>
+          <a:bodyPr/>
+          <a:p/>
+        </p:txBody>
       </p:sp>
       <p:sp>
         <p:nvSpPr>
@@ -34515,6 +35531,10 @@
           </a:solidFill>
           <a:ln/>
         </p:spPr>
+        <p:txBody>
+          <a:bodyPr/>
+          <a:p/>
+        </p:txBody>
       </p:sp>
       <p:sp>
         <p:nvSpPr>
@@ -34620,6 +35640,10 @@
           </a:solidFill>
           <a:ln/>
         </p:spPr>
+        <p:txBody>
+          <a:bodyPr/>
+          <a:p/>
+        </p:txBody>
       </p:sp>
       <p:sp>
         <p:nvSpPr>
@@ -34725,6 +35749,10 @@
           </a:solidFill>
           <a:ln/>
         </p:spPr>
+        <p:txBody>
+          <a:bodyPr/>
+          <a:p/>
+        </p:txBody>
       </p:sp>
       <p:sp>
         <p:nvSpPr>
@@ -34830,6 +35858,10 @@
           </a:solidFill>
           <a:ln/>
         </p:spPr>
+        <p:txBody>
+          <a:bodyPr/>
+          <a:p/>
+        </p:txBody>
       </p:sp>
       <p:sp>
         <p:nvSpPr>
@@ -34935,6 +35967,10 @@
           </a:solidFill>
           <a:ln/>
         </p:spPr>
+        <p:txBody>
+          <a:bodyPr/>
+          <a:p/>
+        </p:txBody>
       </p:sp>
       <p:sp>
         <p:nvSpPr>
@@ -35113,6 +36149,10 @@
           </a:gradFill>
           <a:ln/>
         </p:spPr>
+        <p:txBody>
+          <a:bodyPr/>
+          <a:p/>
+        </p:txBody>
       </p:sp>
       <p:sp>
         <p:nvSpPr>
@@ -35157,6 +36197,10 @@
           </a:solidFill>
           <a:ln/>
         </p:spPr>
+        <p:txBody>
+          <a:bodyPr/>
+          <a:p/>
+        </p:txBody>
       </p:sp>
       <p:sp>
         <p:nvSpPr>
@@ -35215,6 +36259,10 @@
             </a:outerShdw>
           </a:effectLst>
         </p:spPr>
+        <p:txBody>
+          <a:bodyPr/>
+          <a:p/>
+        </p:txBody>
       </p:sp>
       <p:sp>
         <p:nvSpPr>
@@ -35320,6 +36368,10 @@
           </a:solidFill>
           <a:ln/>
         </p:spPr>
+        <p:txBody>
+          <a:bodyPr/>
+          <a:p/>
+        </p:txBody>
       </p:sp>
       <p:sp>
         <p:nvSpPr>
@@ -35364,6 +36416,10 @@
           </a:solidFill>
           <a:ln/>
         </p:spPr>
+        <p:txBody>
+          <a:bodyPr/>
+          <a:p/>
+        </p:txBody>
       </p:sp>
       <p:sp>
         <p:nvSpPr>
@@ -35392,7 +36448,7 @@
               </a:lnSpc>
             </a:pPr>
             <a:r>
-              <a:rPr lang="en-US" sz="6940" b="1" dirty="0">
+              <a:rPr lang="en-US" sz="3600" b="1" dirty="0">
                 <a:solidFill>
                   <a:srgbClr val="FFFFFF"/>
                 </a:solidFill>
@@ -35411,7 +36467,7 @@
               </a:lnSpc>
             </a:pPr>
             <a:r>
-              <a:rPr lang="en-US" sz="6940" b="1" dirty="0">
+              <a:rPr lang="en-US" sz="3600" b="1" dirty="0">
                 <a:solidFill>
                   <a:srgbClr val="DDFF00"/>
                 </a:solidFill>
@@ -35568,6 +36624,10 @@
           </a:solidFill>
           <a:ln/>
         </p:spPr>
+        <p:txBody>
+          <a:bodyPr/>
+          <a:p/>
+        </p:txBody>
       </p:sp>
       <p:sp>
         <p:nvSpPr>
@@ -35612,6 +36672,10 @@
           </a:solidFill>
           <a:ln/>
         </p:spPr>
+        <p:txBody>
+          <a:bodyPr/>
+          <a:p/>
+        </p:txBody>
       </p:sp>
       <p:sp>
         <p:nvSpPr>
@@ -35656,6 +36720,10 @@
           </a:solidFill>
           <a:ln/>
         </p:spPr>
+        <p:txBody>
+          <a:bodyPr/>
+          <a:p/>
+        </p:txBody>
       </p:sp>
       <p:sp>
         <p:nvSpPr>
@@ -36110,6 +37178,10 @@
           </a:gradFill>
           <a:ln/>
         </p:spPr>
+        <p:txBody>
+          <a:bodyPr/>
+          <a:p/>
+        </p:txBody>
       </p:sp>
       <p:sp>
         <p:nvSpPr>
@@ -36161,6 +37233,10 @@
             <a:prstDash val="solid"/>
           </a:ln>
         </p:spPr>
+        <p:txBody>
+          <a:bodyPr/>
+          <a:p/>
+        </p:txBody>
       </p:sp>
       <p:sp>
         <p:nvSpPr>
@@ -36205,6 +37281,10 @@
           </a:solidFill>
           <a:ln/>
         </p:spPr>
+        <p:txBody>
+          <a:bodyPr/>
+          <a:p/>
+        </p:txBody>
       </p:sp>
       <p:sp>
         <p:nvSpPr>
@@ -36290,6 +37370,10 @@
           </a:solidFill>
           <a:ln/>
         </p:spPr>
+        <p:txBody>
+          <a:bodyPr/>
+          <a:p/>
+        </p:txBody>
       </p:sp>
       <p:sp>
         <p:nvSpPr>
@@ -36359,7 +37443,7 @@
               </a:lnSpc>
             </a:pPr>
             <a:r>
-              <a:rPr lang="en-US" sz="5400" b="1" dirty="0">
+              <a:rPr lang="en-US" sz="3600" b="1" dirty="0">
                 <a:solidFill>
                   <a:srgbClr val="FFFFFF"/>
                 </a:solidFill>
@@ -36378,7 +37462,7 @@
               </a:lnSpc>
             </a:pPr>
             <a:r>
-              <a:rPr lang="en-US" sz="5400" b="1" dirty="0">
+              <a:rPr lang="en-US" sz="3600" b="1" dirty="0">
                 <a:solidFill>
                   <a:srgbClr val="DDFF00"/>
                 </a:solidFill>
@@ -36478,6 +37562,10 @@
           </a:solidFill>
           <a:ln/>
         </p:spPr>
+        <p:txBody>
+          <a:bodyPr/>
+          <a:p/>
+        </p:txBody>
       </p:sp>
       <p:sp>
         <p:nvSpPr>
@@ -36522,6 +37610,10 @@
           </a:solidFill>
           <a:ln/>
         </p:spPr>
+        <p:txBody>
+          <a:bodyPr/>
+          <a:p/>
+        </p:txBody>
       </p:sp>
       <p:sp>
         <p:nvSpPr>
@@ -36566,6 +37658,10 @@
           </a:solidFill>
           <a:ln/>
         </p:spPr>
+        <p:txBody>
+          <a:bodyPr/>
+          <a:p/>
+        </p:txBody>
       </p:sp>
     </p:spTree>
   </p:cSld>
@@ -36642,6 +37738,10 @@
           </a:solidFill>
           <a:ln/>
         </p:spPr>
+        <p:txBody>
+          <a:bodyPr/>
+          <a:p/>
+        </p:txBody>
       </p:sp>
       <p:sp>
         <p:nvSpPr>
@@ -36711,7 +37811,7 @@
               </a:lnSpc>
             </a:pPr>
             <a:r>
-              <a:rPr lang="en-US" sz="2700" b="1" dirty="0">
+              <a:rPr lang="en-US" sz="3600" b="1" dirty="0">
                 <a:solidFill>
                   <a:srgbClr val="FFFFFF"/>
                 </a:solidFill>
@@ -36768,6 +37868,10 @@
           </a:solidFill>
           <a:ln/>
         </p:spPr>
+        <p:txBody>
+          <a:bodyPr/>
+          <a:p/>
+        </p:txBody>
       </p:sp>
       <p:sp>
         <p:nvSpPr>
@@ -36873,6 +37977,10 @@
           </a:solidFill>
           <a:ln/>
         </p:spPr>
+        <p:txBody>
+          <a:bodyPr/>
+          <a:p/>
+        </p:txBody>
       </p:sp>
       <p:sp>
         <p:nvSpPr>
@@ -37160,6 +38268,10 @@
           </a:solidFill>
           <a:ln/>
         </p:spPr>
+        <p:txBody>
+          <a:bodyPr/>
+          <a:p/>
+        </p:txBody>
       </p:sp>
       <p:sp>
         <p:nvSpPr>
@@ -37331,6 +38443,10 @@
           </a:solidFill>
           <a:ln/>
         </p:spPr>
+        <p:txBody>
+          <a:bodyPr/>
+          <a:p/>
+        </p:txBody>
       </p:sp>
       <p:sp>
         <p:nvSpPr>
@@ -37616,6 +38732,10 @@
           </a:solidFill>
           <a:ln/>
         </p:spPr>
+        <p:txBody>
+          <a:bodyPr/>
+          <a:p/>
+        </p:txBody>
       </p:sp>
       <p:sp>
         <p:nvSpPr>
@@ -37730,6 +38850,10 @@
           </a:solidFill>
           <a:ln/>
         </p:spPr>
+        <p:txBody>
+          <a:bodyPr/>
+          <a:p/>
+        </p:txBody>
       </p:sp>
       <p:sp>
         <p:nvSpPr>
@@ -37879,6 +39003,10 @@
             <a:prstDash val="solid"/>
           </a:ln>
         </p:spPr>
+        <p:txBody>
+          <a:bodyPr/>
+          <a:p/>
+        </p:txBody>
       </p:sp>
       <p:sp>
         <p:nvSpPr>
@@ -38076,6 +39204,10 @@
           </a:solidFill>
           <a:ln/>
         </p:spPr>
+        <p:txBody>
+          <a:bodyPr/>
+          <a:p/>
+        </p:txBody>
       </p:sp>
       <p:sp>
         <p:nvSpPr>
@@ -38234,6 +39366,10 @@
           </a:solidFill>
           <a:ln/>
         </p:spPr>
+        <p:txBody>
+          <a:bodyPr/>
+          <a:p/>
+        </p:txBody>
       </p:sp>
       <p:sp>
         <p:nvSpPr>
@@ -38472,6 +39608,10 @@
           </a:solidFill>
           <a:ln/>
         </p:spPr>
+        <p:txBody>
+          <a:bodyPr/>
+          <a:p/>
+        </p:txBody>
       </p:sp>
       <p:sp>
         <p:nvSpPr>
@@ -38541,7 +39681,7 @@
               </a:lnSpc>
             </a:pPr>
             <a:r>
-              <a:rPr lang="en-US" sz="2250" b="1" dirty="0">
+              <a:rPr lang="en-US" sz="3600" b="1" dirty="0">
                 <a:solidFill>
                   <a:srgbClr val="FFFFFF"/>
                 </a:solidFill>
@@ -38598,6 +39738,10 @@
           </a:solidFill>
           <a:ln/>
         </p:spPr>
+        <p:txBody>
+          <a:bodyPr/>
+          <a:p/>
+        </p:txBody>
       </p:sp>
       <p:sp>
         <p:nvSpPr>
@@ -38790,6 +39934,10 @@
             <a:prstDash val="solid"/>
           </a:ln>
         </p:spPr>
+        <p:txBody>
+          <a:bodyPr/>
+          <a:p/>
+        </p:txBody>
       </p:sp>
       <p:sp>
         <p:nvSpPr>
@@ -38875,6 +40023,10 @@
           </a:solidFill>
           <a:ln/>
         </p:spPr>
+        <p:txBody>
+          <a:bodyPr/>
+          <a:p/>
+        </p:txBody>
       </p:sp>
       <p:sp>
         <p:nvSpPr>
@@ -38987,6 +40139,10 @@
           </a:solidFill>
           <a:ln/>
         </p:spPr>
+        <p:txBody>
+          <a:bodyPr/>
+          <a:p/>
+        </p:txBody>
       </p:sp>
       <p:sp>
         <p:nvSpPr>
@@ -39115,6 +40271,10 @@
           </a:solidFill>
           <a:ln/>
         </p:spPr>
+        <p:txBody>
+          <a:bodyPr/>
+          <a:p/>
+        </p:txBody>
       </p:sp>
       <p:sp>
         <p:nvSpPr>
@@ -39227,6 +40387,10 @@
           </a:solidFill>
           <a:ln/>
         </p:spPr>
+        <p:txBody>
+          <a:bodyPr/>
+          <a:p/>
+        </p:txBody>
       </p:sp>
       <p:sp>
         <p:nvSpPr>
@@ -39355,6 +40519,10 @@
           </a:solidFill>
           <a:ln/>
         </p:spPr>
+        <p:txBody>
+          <a:bodyPr/>
+          <a:p/>
+        </p:txBody>
       </p:sp>
       <p:sp>
         <p:nvSpPr>
@@ -39467,6 +40635,10 @@
           </a:solidFill>
           <a:ln/>
         </p:spPr>
+        <p:txBody>
+          <a:bodyPr/>
+          <a:p/>
+        </p:txBody>
       </p:sp>
       <p:sp>
         <p:nvSpPr>
@@ -39595,6 +40767,10 @@
           </a:solidFill>
           <a:ln/>
         </p:spPr>
+        <p:txBody>
+          <a:bodyPr/>
+          <a:p/>
+        </p:txBody>
       </p:sp>
       <p:sp>
         <p:nvSpPr>
@@ -39707,6 +40883,10 @@
           </a:solidFill>
           <a:ln/>
         </p:spPr>
+        <p:txBody>
+          <a:bodyPr/>
+          <a:p/>
+        </p:txBody>
       </p:sp>
       <p:sp>
         <p:nvSpPr>
@@ -39875,6 +41055,10 @@
           </a:gradFill>
           <a:ln/>
         </p:spPr>
+        <p:txBody>
+          <a:bodyPr/>
+          <a:p/>
+        </p:txBody>
       </p:sp>
       <p:sp>
         <p:nvSpPr>
@@ -40008,6 +41192,10 @@
             <a:prstDash val="solid"/>
           </a:ln>
         </p:spPr>
+        <p:txBody>
+          <a:bodyPr/>
+          <a:p/>
+        </p:txBody>
       </p:sp>
       <p:sp>
         <p:nvSpPr>
@@ -40164,6 +41352,10 @@
             <a:prstDash val="solid"/>
           </a:ln>
         </p:spPr>
+        <p:txBody>
+          <a:bodyPr/>
+          <a:p/>
+        </p:txBody>
       </p:sp>
       <p:sp>
         <p:nvSpPr>
@@ -40320,6 +41512,10 @@
             <a:prstDash val="solid"/>
           </a:ln>
         </p:spPr>
+        <p:txBody>
+          <a:bodyPr/>
+          <a:p/>
+        </p:txBody>
       </p:sp>
       <p:sp>
         <p:nvSpPr>
@@ -40469,6 +41665,10 @@
           </a:solidFill>
           <a:ln/>
         </p:spPr>
+        <p:txBody>
+          <a:bodyPr/>
+          <a:p/>
+        </p:txBody>
       </p:sp>
       <p:sp>
         <p:nvSpPr>
@@ -40685,6 +41885,10 @@
           </a:gradFill>
           <a:ln/>
         </p:spPr>
+        <p:txBody>
+          <a:bodyPr/>
+          <a:p/>
+        </p:txBody>
       </p:sp>
       <p:sp>
         <p:nvSpPr>
@@ -40736,6 +41940,10 @@
             <a:prstDash val="solid"/>
           </a:ln>
         </p:spPr>
+        <p:txBody>
+          <a:bodyPr/>
+          <a:p/>
+        </p:txBody>
       </p:sp>
       <p:sp>
         <p:nvSpPr>
@@ -40780,6 +41988,10 @@
           </a:solidFill>
           <a:ln/>
         </p:spPr>
+        <p:txBody>
+          <a:bodyPr/>
+          <a:p/>
+        </p:txBody>
       </p:sp>
       <p:sp>
         <p:nvSpPr>
@@ -40865,6 +42077,10 @@
           </a:solidFill>
           <a:ln/>
         </p:spPr>
+        <p:txBody>
+          <a:bodyPr/>
+          <a:p/>
+        </p:txBody>
       </p:sp>
       <p:sp>
         <p:nvSpPr>
@@ -40934,7 +42150,7 @@
               </a:lnSpc>
             </a:pPr>
             <a:r>
-              <a:rPr lang="en-US" sz="5400" b="1" dirty="0">
+              <a:rPr lang="en-US" sz="3600" b="1" dirty="0">
                 <a:solidFill>
                   <a:srgbClr val="FFFFFF"/>
                 </a:solidFill>
@@ -40953,7 +42169,7 @@
               </a:lnSpc>
             </a:pPr>
             <a:r>
-              <a:rPr lang="en-US" sz="5400" b="1" dirty="0">
+              <a:rPr lang="en-US" sz="3600" b="1" dirty="0">
                 <a:solidFill>
                   <a:srgbClr val="DDFF00"/>
                 </a:solidFill>
@@ -41053,6 +42269,10 @@
           </a:solidFill>
           <a:ln/>
         </p:spPr>
+        <p:txBody>
+          <a:bodyPr/>
+          <a:p/>
+        </p:txBody>
       </p:sp>
       <p:sp>
         <p:nvSpPr>
@@ -41097,6 +42317,10 @@
           </a:solidFill>
           <a:ln/>
         </p:spPr>
+        <p:txBody>
+          <a:bodyPr/>
+          <a:p/>
+        </p:txBody>
       </p:sp>
       <p:sp>
         <p:nvSpPr>
@@ -41141,6 +42365,10 @@
           </a:solidFill>
           <a:ln/>
         </p:spPr>
+        <p:txBody>
+          <a:bodyPr/>
+          <a:p/>
+        </p:txBody>
       </p:sp>
     </p:spTree>
   </p:cSld>
@@ -41217,6 +42445,10 @@
           </a:solidFill>
           <a:ln/>
         </p:spPr>
+        <p:txBody>
+          <a:bodyPr/>
+          <a:p/>
+        </p:txBody>
       </p:sp>
       <p:sp>
         <p:nvSpPr>
@@ -41286,7 +42518,7 @@
               </a:lnSpc>
             </a:pPr>
             <a:r>
-              <a:rPr lang="en-US" sz="2337" b="1" dirty="0">
+              <a:rPr lang="en-US" sz="3600" b="1" dirty="0">
                 <a:solidFill>
                   <a:srgbClr val="FFFFFF"/>
                 </a:solidFill>
@@ -41343,6 +42575,10 @@
           </a:solidFill>
           <a:ln/>
         </p:spPr>
+        <p:txBody>
+          <a:bodyPr/>
+          <a:p/>
+        </p:txBody>
       </p:sp>
       <p:sp>
         <p:nvSpPr>
@@ -41535,6 +42771,10 @@
             <a:prstDash val="solid"/>
           </a:ln>
         </p:spPr>
+        <p:txBody>
+          <a:bodyPr/>
+          <a:p/>
+        </p:txBody>
       </p:sp>
       <p:sp>
         <p:nvSpPr>
@@ -41620,6 +42860,10 @@
           </a:solidFill>
           <a:ln/>
         </p:spPr>
+        <p:txBody>
+          <a:bodyPr/>
+          <a:p/>
+        </p:txBody>
       </p:sp>
       <p:sp>
         <p:nvSpPr>
@@ -41880,6 +43124,10 @@
           </a:solidFill>
           <a:ln/>
         </p:spPr>
+        <p:txBody>
+          <a:bodyPr/>
+          <a:p/>
+        </p:txBody>
       </p:sp>
       <p:sp>
         <p:nvSpPr>
@@ -42078,6 +43326,10 @@
           </a:solidFill>
           <a:ln/>
         </p:spPr>
+        <p:txBody>
+          <a:bodyPr/>
+          <a:p/>
+        </p:txBody>
       </p:sp>
       <p:sp>
         <p:nvSpPr>
@@ -42312,6 +43564,10 @@
           </a:solidFill>
           <a:ln/>
         </p:spPr>
+        <p:txBody>
+          <a:bodyPr/>
+          <a:p/>
+        </p:txBody>
       </p:sp>
       <p:sp>
         <p:nvSpPr>
@@ -42517,6 +43773,10 @@
             <a:prstDash val="solid"/>
           </a:ln>
         </p:spPr>
+        <p:txBody>
+          <a:bodyPr/>
+          <a:p/>
+        </p:txBody>
       </p:sp>
       <p:sp>
         <p:nvSpPr>
@@ -42673,6 +43933,10 @@
             <a:prstDash val="solid"/>
           </a:ln>
         </p:spPr>
+        <p:txBody>
+          <a:bodyPr/>
+          <a:p/>
+        </p:txBody>
       </p:sp>
       <p:sp>
         <p:nvSpPr>
@@ -42829,6 +44093,10 @@
             <a:prstDash val="solid"/>
           </a:ln>
         </p:spPr>
+        <p:txBody>
+          <a:bodyPr/>
+          <a:p/>
+        </p:txBody>
       </p:sp>
       <p:sp>
         <p:nvSpPr>
@@ -43018,6 +44286,10 @@
           </a:gradFill>
           <a:ln/>
         </p:spPr>
+        <p:txBody>
+          <a:bodyPr/>
+          <a:p/>
+        </p:txBody>
       </p:sp>
       <p:sp>
         <p:nvSpPr>
@@ -43151,6 +44423,10 @@
             <a:prstDash val="solid"/>
           </a:ln>
         </p:spPr>
+        <p:txBody>
+          <a:bodyPr/>
+          <a:p/>
+        </p:txBody>
       </p:sp>
       <p:sp>
         <p:nvSpPr>
@@ -43236,6 +44512,10 @@
           </a:solidFill>
           <a:ln/>
         </p:spPr>
+        <p:txBody>
+          <a:bodyPr/>
+          <a:p/>
+        </p:txBody>
       </p:sp>
       <p:sp>
         <p:nvSpPr>
@@ -43341,6 +44621,10 @@
           </a:solidFill>
           <a:ln/>
         </p:spPr>
+        <p:txBody>
+          <a:bodyPr/>
+          <a:p/>
+        </p:txBody>
       </p:sp>
       <p:sp>
         <p:nvSpPr>
@@ -43446,6 +44730,10 @@
           </a:solidFill>
           <a:ln/>
         </p:spPr>
+        <p:txBody>
+          <a:bodyPr/>
+          <a:p/>
+        </p:txBody>
       </p:sp>
       <p:sp>
         <p:nvSpPr>
@@ -43551,6 +44839,10 @@
           </a:solidFill>
           <a:ln/>
         </p:spPr>
+        <p:txBody>
+          <a:bodyPr/>
+          <a:p/>
+        </p:txBody>
       </p:sp>
       <p:sp>
         <p:nvSpPr>
@@ -43688,6 +44980,10 @@
           </a:solidFill>
           <a:ln/>
         </p:spPr>
+        <p:txBody>
+          <a:bodyPr/>
+          <a:p/>
+        </p:txBody>
       </p:sp>
       <p:sp>
         <p:nvSpPr>
@@ -43757,7 +45053,7 @@
               </a:lnSpc>
             </a:pPr>
             <a:r>
-              <a:rPr lang="en-US" sz="2250" b="1" dirty="0">
+              <a:rPr lang="en-US" sz="3600" b="1" dirty="0">
                 <a:solidFill>
                   <a:srgbClr val="FFFFFF"/>
                 </a:solidFill>
@@ -43814,6 +45110,10 @@
           </a:solidFill>
           <a:ln/>
         </p:spPr>
+        <p:txBody>
+          <a:bodyPr/>
+          <a:p/>
+        </p:txBody>
       </p:sp>
       <p:sp>
         <p:nvSpPr>
@@ -44006,6 +45306,10 @@
             <a:prstDash val="solid"/>
           </a:ln>
         </p:spPr>
+        <p:txBody>
+          <a:bodyPr/>
+          <a:p/>
+        </p:txBody>
       </p:sp>
       <p:sp>
         <p:nvSpPr>
@@ -44091,6 +45395,10 @@
           </a:solidFill>
           <a:ln/>
         </p:spPr>
+        <p:txBody>
+          <a:bodyPr/>
+          <a:p/>
+        </p:txBody>
       </p:sp>
       <p:sp>
         <p:nvSpPr>
@@ -44135,6 +45443,10 @@
           </a:solidFill>
           <a:ln/>
         </p:spPr>
+        <p:txBody>
+          <a:bodyPr/>
+          <a:p/>
+        </p:txBody>
       </p:sp>
       <p:sp>
         <p:nvSpPr>
@@ -44282,6 +45594,10 @@
           </a:solidFill>
           <a:ln/>
         </p:spPr>
+        <p:txBody>
+          <a:bodyPr/>
+          <a:p/>
+        </p:txBody>
       </p:sp>
       <p:sp>
         <p:nvSpPr>
@@ -44410,6 +45726,10 @@
           </a:solidFill>
           <a:ln/>
         </p:spPr>
+        <p:txBody>
+          <a:bodyPr/>
+          <a:p/>
+        </p:txBody>
       </p:sp>
       <p:sp>
         <p:nvSpPr>
@@ -44454,6 +45774,10 @@
           </a:solidFill>
           <a:ln/>
         </p:spPr>
+        <p:txBody>
+          <a:bodyPr/>
+          <a:p/>
+        </p:txBody>
       </p:sp>
       <p:sp>
         <p:nvSpPr>
@@ -44544,6 +45868,10 @@
           </a:solidFill>
           <a:ln/>
         </p:spPr>
+        <p:txBody>
+          <a:bodyPr/>
+          <a:p/>
+        </p:txBody>
       </p:sp>
       <p:sp>
         <p:nvSpPr>
@@ -44672,6 +46000,10 @@
           </a:solidFill>
           <a:ln/>
         </p:spPr>
+        <p:txBody>
+          <a:bodyPr/>
+          <a:p/>
+        </p:txBody>
       </p:sp>
       <p:sp>
         <p:nvSpPr>
@@ -44716,6 +46048,10 @@
           </a:solidFill>
           <a:ln/>
         </p:spPr>
+        <p:txBody>
+          <a:bodyPr/>
+          <a:p/>
+        </p:txBody>
       </p:sp>
       <p:sp>
         <p:nvSpPr>
@@ -44870,6 +46206,10 @@
           </a:solidFill>
           <a:ln/>
         </p:spPr>
+        <p:txBody>
+          <a:bodyPr/>
+          <a:p/>
+        </p:txBody>
       </p:sp>
       <p:sp>
         <p:nvSpPr>
@@ -44998,6 +46338,10 @@
           </a:solidFill>
           <a:ln/>
         </p:spPr>
+        <p:txBody>
+          <a:bodyPr/>
+          <a:p/>
+        </p:txBody>
       </p:sp>
       <p:sp>
         <p:nvSpPr>
@@ -45042,6 +46386,10 @@
           </a:solidFill>
           <a:ln/>
         </p:spPr>
+        <p:txBody>
+          <a:bodyPr/>
+          <a:p/>
+        </p:txBody>
       </p:sp>
       <p:sp>
         <p:nvSpPr>
@@ -45154,6 +46502,10 @@
           </a:solidFill>
           <a:ln/>
         </p:spPr>
+        <p:txBody>
+          <a:bodyPr/>
+          <a:p/>
+        </p:txBody>
       </p:sp>
       <p:sp>
         <p:nvSpPr>
@@ -45289,6 +46641,10 @@
             <a:prstDash val="solid"/>
           </a:ln>
         </p:spPr>
+        <p:txBody>
+          <a:bodyPr/>
+          <a:p/>
+        </p:txBody>
       </p:sp>
       <p:sp>
         <p:nvSpPr>
@@ -45374,6 +46730,10 @@
           </a:solidFill>
           <a:ln/>
         </p:spPr>
+        <p:txBody>
+          <a:bodyPr/>
+          <a:p/>
+        </p:txBody>
       </p:sp>
       <p:sp>
         <p:nvSpPr>
@@ -45459,6 +46819,10 @@
           </a:solidFill>
           <a:ln/>
         </p:spPr>
+        <p:txBody>
+          <a:bodyPr/>
+          <a:p/>
+        </p:txBody>
       </p:sp>
       <p:sp>
         <p:nvSpPr>
@@ -45544,6 +46908,10 @@
           </a:solidFill>
           <a:ln/>
         </p:spPr>
+        <p:txBody>
+          <a:bodyPr/>
+          <a:p/>
+        </p:txBody>
       </p:sp>
       <p:sp>
         <p:nvSpPr>
@@ -45629,6 +46997,10 @@
           </a:solidFill>
           <a:ln/>
         </p:spPr>
+        <p:txBody>
+          <a:bodyPr/>
+          <a:p/>
+        </p:txBody>
       </p:sp>
       <p:sp>
         <p:nvSpPr>
@@ -45714,6 +47086,10 @@
           </a:solidFill>
           <a:ln/>
         </p:spPr>
+        <p:txBody>
+          <a:bodyPr/>
+          <a:p/>
+        </p:txBody>
       </p:sp>
       <p:sp>
         <p:nvSpPr>
@@ -45799,6 +47175,10 @@
           </a:solidFill>
           <a:ln/>
         </p:spPr>
+        <p:txBody>
+          <a:bodyPr/>
+          <a:p/>
+        </p:txBody>
       </p:sp>
       <p:sp>
         <p:nvSpPr>
@@ -45884,6 +47264,10 @@
           </a:solidFill>
           <a:ln/>
         </p:spPr>
+        <p:txBody>
+          <a:bodyPr/>
+          <a:p/>
+        </p:txBody>
       </p:sp>
       <p:sp>
         <p:nvSpPr>
@@ -45969,6 +47353,10 @@
           </a:solidFill>
           <a:ln/>
         </p:spPr>
+        <p:txBody>
+          <a:bodyPr/>
+          <a:p/>
+        </p:txBody>
       </p:sp>
       <p:sp>
         <p:nvSpPr>
@@ -46054,6 +47442,10 @@
           </a:solidFill>
           <a:ln/>
         </p:spPr>
+        <p:txBody>
+          <a:bodyPr/>
+          <a:p/>
+        </p:txBody>
       </p:sp>
       <p:sp>
         <p:nvSpPr>
@@ -46139,6 +47531,10 @@
           </a:solidFill>
           <a:ln/>
         </p:spPr>
+        <p:txBody>
+          <a:bodyPr/>
+          <a:p/>
+        </p:txBody>
       </p:sp>
       <p:sp>
         <p:nvSpPr>
@@ -46224,6 +47620,10 @@
           </a:solidFill>
           <a:ln/>
         </p:spPr>
+        <p:txBody>
+          <a:bodyPr/>
+          <a:p/>
+        </p:txBody>
       </p:sp>
       <p:sp>
         <p:nvSpPr>
@@ -46440,6 +47840,10 @@
           </a:gradFill>
           <a:ln/>
         </p:spPr>
+        <p:txBody>
+          <a:bodyPr/>
+          <a:p/>
+        </p:txBody>
       </p:sp>
       <p:sp>
         <p:nvSpPr>
@@ -46491,6 +47895,10 @@
             <a:prstDash val="solid"/>
           </a:ln>
         </p:spPr>
+        <p:txBody>
+          <a:bodyPr/>
+          <a:p/>
+        </p:txBody>
       </p:sp>
       <p:sp>
         <p:nvSpPr>
@@ -46535,6 +47943,10 @@
           </a:solidFill>
           <a:ln/>
         </p:spPr>
+        <p:txBody>
+          <a:bodyPr/>
+          <a:p/>
+        </p:txBody>
       </p:sp>
       <p:sp>
         <p:nvSpPr>
@@ -46620,6 +48032,10 @@
           </a:solidFill>
           <a:ln/>
         </p:spPr>
+        <p:txBody>
+          <a:bodyPr/>
+          <a:p/>
+        </p:txBody>
       </p:sp>
       <p:sp>
         <p:nvSpPr>
@@ -46689,7 +48105,7 @@
               </a:lnSpc>
             </a:pPr>
             <a:r>
-              <a:rPr lang="en-US" sz="5400" b="1" dirty="0">
+              <a:rPr lang="en-US" sz="3600" b="1" dirty="0">
                 <a:solidFill>
                   <a:srgbClr val="FFFFFF"/>
                 </a:solidFill>
@@ -46708,7 +48124,7 @@
               </a:lnSpc>
             </a:pPr>
             <a:r>
-              <a:rPr lang="en-US" sz="5400" b="1" dirty="0">
+              <a:rPr lang="en-US" sz="3600" b="1" dirty="0">
                 <a:solidFill>
                   <a:srgbClr val="DDFF00"/>
                 </a:solidFill>
@@ -46808,6 +48224,10 @@
           </a:solidFill>
           <a:ln/>
         </p:spPr>
+        <p:txBody>
+          <a:bodyPr/>
+          <a:p/>
+        </p:txBody>
       </p:sp>
       <p:sp>
         <p:nvSpPr>
@@ -46852,6 +48272,10 @@
           </a:solidFill>
           <a:ln/>
         </p:spPr>
+        <p:txBody>
+          <a:bodyPr/>
+          <a:p/>
+        </p:txBody>
       </p:sp>
       <p:sp>
         <p:nvSpPr>
@@ -46896,6 +48320,10 @@
           </a:solidFill>
           <a:ln/>
         </p:spPr>
+        <p:txBody>
+          <a:bodyPr/>
+          <a:p/>
+        </p:txBody>
       </p:sp>
     </p:spTree>
   </p:cSld>

</xml_diff>